<commit_message>
Added Command & Switch PCBs
</commit_message>
<xml_diff>
--- a/design-proposal.pptx
+++ b/design-proposal.pptx
@@ -8,7 +8,7 @@
     <p:sldId id="256" r:id="rId2"/>
   </p:sldIdLst>
   <p:sldSz cx="15119350" cy="10691813"/>
-  <p:notesSz cx="6858000" cy="9144000"/>
+  <p:notesSz cx="10234613" cy="14663738"/>
   <p:defaultTextStyle>
     <a:defPPr>
       <a:defRPr lang="en-US"/>
@@ -264,7 +264,7 @@
           <a:p>
             <a:fld id="{C9EA1182-88C4-47C8-A7E1-E417A068045C}" type="datetimeFigureOut">
               <a:rPr lang="en-GB" smtClean="0"/>
-              <a:t>23/11/2025</a:t>
+              <a:t>10/12/2025</a:t>
             </a:fld>
             <a:endParaRPr lang="en-GB"/>
           </a:p>
@@ -434,7 +434,7 @@
           <a:p>
             <a:fld id="{C9EA1182-88C4-47C8-A7E1-E417A068045C}" type="datetimeFigureOut">
               <a:rPr lang="en-GB" smtClean="0"/>
-              <a:t>23/11/2025</a:t>
+              <a:t>10/12/2025</a:t>
             </a:fld>
             <a:endParaRPr lang="en-GB"/>
           </a:p>
@@ -614,7 +614,7 @@
           <a:p>
             <a:fld id="{C9EA1182-88C4-47C8-A7E1-E417A068045C}" type="datetimeFigureOut">
               <a:rPr lang="en-GB" smtClean="0"/>
-              <a:t>23/11/2025</a:t>
+              <a:t>10/12/2025</a:t>
             </a:fld>
             <a:endParaRPr lang="en-GB"/>
           </a:p>
@@ -784,7 +784,7 @@
           <a:p>
             <a:fld id="{C9EA1182-88C4-47C8-A7E1-E417A068045C}" type="datetimeFigureOut">
               <a:rPr lang="en-GB" smtClean="0"/>
-              <a:t>23/11/2025</a:t>
+              <a:t>10/12/2025</a:t>
             </a:fld>
             <a:endParaRPr lang="en-GB"/>
           </a:p>
@@ -1030,7 +1030,7 @@
           <a:p>
             <a:fld id="{C9EA1182-88C4-47C8-A7E1-E417A068045C}" type="datetimeFigureOut">
               <a:rPr lang="en-GB" smtClean="0"/>
-              <a:t>23/11/2025</a:t>
+              <a:t>10/12/2025</a:t>
             </a:fld>
             <a:endParaRPr lang="en-GB"/>
           </a:p>
@@ -1262,7 +1262,7 @@
           <a:p>
             <a:fld id="{C9EA1182-88C4-47C8-A7E1-E417A068045C}" type="datetimeFigureOut">
               <a:rPr lang="en-GB" smtClean="0"/>
-              <a:t>23/11/2025</a:t>
+              <a:t>10/12/2025</a:t>
             </a:fld>
             <a:endParaRPr lang="en-GB"/>
           </a:p>
@@ -1629,7 +1629,7 @@
           <a:p>
             <a:fld id="{C9EA1182-88C4-47C8-A7E1-E417A068045C}" type="datetimeFigureOut">
               <a:rPr lang="en-GB" smtClean="0"/>
-              <a:t>23/11/2025</a:t>
+              <a:t>10/12/2025</a:t>
             </a:fld>
             <a:endParaRPr lang="en-GB"/>
           </a:p>
@@ -1747,7 +1747,7 @@
           <a:p>
             <a:fld id="{C9EA1182-88C4-47C8-A7E1-E417A068045C}" type="datetimeFigureOut">
               <a:rPr lang="en-GB" smtClean="0"/>
-              <a:t>23/11/2025</a:t>
+              <a:t>10/12/2025</a:t>
             </a:fld>
             <a:endParaRPr lang="en-GB"/>
           </a:p>
@@ -1842,7 +1842,7 @@
           <a:p>
             <a:fld id="{C9EA1182-88C4-47C8-A7E1-E417A068045C}" type="datetimeFigureOut">
               <a:rPr lang="en-GB" smtClean="0"/>
-              <a:t>23/11/2025</a:t>
+              <a:t>10/12/2025</a:t>
             </a:fld>
             <a:endParaRPr lang="en-GB"/>
           </a:p>
@@ -2119,7 +2119,7 @@
           <a:p>
             <a:fld id="{C9EA1182-88C4-47C8-A7E1-E417A068045C}" type="datetimeFigureOut">
               <a:rPr lang="en-GB" smtClean="0"/>
-              <a:t>23/11/2025</a:t>
+              <a:t>10/12/2025</a:t>
             </a:fld>
             <a:endParaRPr lang="en-GB"/>
           </a:p>
@@ -2376,7 +2376,7 @@
           <a:p>
             <a:fld id="{C9EA1182-88C4-47C8-A7E1-E417A068045C}" type="datetimeFigureOut">
               <a:rPr lang="en-GB" smtClean="0"/>
-              <a:t>23/11/2025</a:t>
+              <a:t>10/12/2025</a:t>
             </a:fld>
             <a:endParaRPr lang="en-GB"/>
           </a:p>
@@ -2589,7 +2589,7 @@
           <a:p>
             <a:fld id="{C9EA1182-88C4-47C8-A7E1-E417A068045C}" type="datetimeFigureOut">
               <a:rPr lang="en-GB" smtClean="0"/>
-              <a:t>23/11/2025</a:t>
+              <a:t>10/12/2025</a:t>
             </a:fld>
             <a:endParaRPr lang="en-GB"/>
           </a:p>
@@ -2994,6 +2994,98 @@
           <a:chExt cx="0" cy="0"/>
         </a:xfrm>
       </p:grpSpPr>
+      <p:pic>
+        <p:nvPicPr>
+          <p:cNvPr id="3" name="Picture 2">
+            <a:extLst>
+              <a:ext uri="{FF2B5EF4-FFF2-40B4-BE49-F238E27FC236}">
+                <a16:creationId xmlns:a16="http://schemas.microsoft.com/office/drawing/2014/main" id="{3DA1D5AF-C07E-31FE-38AB-6F1807A34511}"/>
+              </a:ext>
+            </a:extLst>
+          </p:cNvPr>
+          <p:cNvPicPr>
+            <a:picLocks noChangeAspect="1"/>
+          </p:cNvPicPr>
+          <p:nvPr/>
+        </p:nvPicPr>
+        <p:blipFill>
+          <a:blip r:embed="rId2"/>
+          <a:srcRect l="7025" t="20577" r="12511" b="33523"/>
+          <a:stretch>
+            <a:fillRect/>
+          </a:stretch>
+        </p:blipFill>
+        <p:spPr>
+          <a:xfrm>
+            <a:off x="446526" y="10096500"/>
+            <a:ext cx="4361335" cy="595313"/>
+          </a:xfrm>
+          <a:prstGeom prst="rect">
+            <a:avLst/>
+          </a:prstGeom>
+        </p:spPr>
+      </p:pic>
+      <p:pic>
+        <p:nvPicPr>
+          <p:cNvPr id="185" name="Picture 184">
+            <a:extLst>
+              <a:ext uri="{FF2B5EF4-FFF2-40B4-BE49-F238E27FC236}">
+                <a16:creationId xmlns:a16="http://schemas.microsoft.com/office/drawing/2014/main" id="{E8460734-C34F-7C8E-0974-B87BF0615870}"/>
+              </a:ext>
+            </a:extLst>
+          </p:cNvPr>
+          <p:cNvPicPr>
+            <a:picLocks noChangeAspect="1"/>
+          </p:cNvPicPr>
+          <p:nvPr/>
+        </p:nvPicPr>
+        <p:blipFill>
+          <a:blip r:embed="rId3"/>
+          <a:srcRect l="24252" t="10959" r="12712" b="14102"/>
+          <a:stretch>
+            <a:fillRect/>
+          </a:stretch>
+        </p:blipFill>
+        <p:spPr>
+          <a:xfrm>
+            <a:off x="4936811" y="7690990"/>
+            <a:ext cx="4361333" cy="2916487"/>
+          </a:xfrm>
+          <a:prstGeom prst="rect">
+            <a:avLst/>
+          </a:prstGeom>
+        </p:spPr>
+      </p:pic>
+      <p:pic>
+        <p:nvPicPr>
+          <p:cNvPr id="12" name="Picture 11" descr="A diagram of a circuit board&#10;&#10;AI-generated content may be incorrect.">
+            <a:extLst>
+              <a:ext uri="{FF2B5EF4-FFF2-40B4-BE49-F238E27FC236}">
+                <a16:creationId xmlns:a16="http://schemas.microsoft.com/office/drawing/2014/main" id="{AD6792F3-0C50-3E7F-0DB1-07092262A550}"/>
+              </a:ext>
+            </a:extLst>
+          </p:cNvPr>
+          <p:cNvPicPr>
+            <a:picLocks noChangeAspect="1"/>
+          </p:cNvPicPr>
+          <p:nvPr/>
+        </p:nvPicPr>
+        <p:blipFill>
+          <a:blip r:embed="rId4"/>
+          <a:stretch>
+            <a:fillRect/>
+          </a:stretch>
+        </p:blipFill>
+        <p:spPr>
+          <a:xfrm>
+            <a:off x="5425858" y="3696236"/>
+            <a:ext cx="2997856" cy="3909646"/>
+          </a:xfrm>
+          <a:prstGeom prst="rect">
+            <a:avLst/>
+          </a:prstGeom>
+        </p:spPr>
+      </p:pic>
       <p:sp>
         <p:nvSpPr>
           <p:cNvPr id="124" name="Rectangle 123">
@@ -3008,7 +3100,7 @@
         </p:nvSpPr>
         <p:spPr>
           <a:xfrm>
-            <a:off x="8767809" y="3744751"/>
+            <a:off x="8767809" y="4421363"/>
             <a:ext cx="6215062" cy="1416674"/>
           </a:xfrm>
           <a:prstGeom prst="rect">
@@ -3042,7 +3134,10 @@
           <a:lstStyle/>
           <a:p>
             <a:pPr algn="ctr"/>
-            <a:endParaRPr lang="en-GB"/>
+            <a:endParaRPr lang="en-GB">
+              <a:latin typeface="Segoe UI" panose="020B0502040204020203" pitchFamily="34" charset="0"/>
+              <a:cs typeface="Segoe UI" panose="020B0502040204020203" pitchFamily="34" charset="0"/>
+            </a:endParaRPr>
           </a:p>
         </p:txBody>
       </p:sp>
@@ -3243,7 +3338,7 @@
         <p:spPr>
           <a:xfrm>
             <a:off x="136479" y="1801514"/>
-            <a:ext cx="4858602" cy="4154984"/>
+            <a:ext cx="4858602" cy="3985706"/>
           </a:xfrm>
           <a:prstGeom prst="rect">
             <a:avLst/>
@@ -3261,7 +3356,7 @@
               <a:buChar char="•"/>
             </a:pPr>
             <a:r>
-              <a:rPr lang="en-GB" sz="1200" dirty="0">
+              <a:rPr lang="en-GB" sz="1100" dirty="0">
                 <a:latin typeface="Segoe UI" panose="020B0502040204020203" pitchFamily="34" charset="0"/>
                 <a:cs typeface="Segoe UI" panose="020B0502040204020203" pitchFamily="34" charset="0"/>
               </a:rPr>
@@ -3274,7 +3369,7 @@
               <a:buChar char="•"/>
             </a:pPr>
             <a:r>
-              <a:rPr lang="en-GB" sz="1200" dirty="0">
+              <a:rPr lang="en-GB" sz="1100" dirty="0">
                 <a:latin typeface="Segoe UI" panose="020B0502040204020203" pitchFamily="34" charset="0"/>
                 <a:cs typeface="Segoe UI" panose="020B0502040204020203" pitchFamily="34" charset="0"/>
               </a:rPr>
@@ -3287,11 +3382,11 @@
               <a:buChar char="•"/>
             </a:pPr>
             <a:r>
-              <a:rPr lang="en-GB" sz="1200" dirty="0">
+              <a:rPr lang="en-GB" sz="1100" dirty="0">
                 <a:latin typeface="Segoe UI" panose="020B0502040204020203" pitchFamily="34" charset="0"/>
                 <a:cs typeface="Segoe UI" panose="020B0502040204020203" pitchFamily="34" charset="0"/>
               </a:rPr>
-              <a:t>There are many existing products for this issue already, but they are either too expensive for no reason due to being sold to businesses or are too simple and not reliable, so I thought ill make my own.</a:t>
+              <a:t>There are many existing products for this issue already, but they are either too expensive for no reason due to being sold to businesses or are too simple and not reliable enough, so I thought I’ll make my own.</a:t>
             </a:r>
           </a:p>
           <a:p>
@@ -3300,7 +3395,7 @@
               <a:buChar char="•"/>
             </a:pPr>
             <a:r>
-              <a:rPr lang="en-GB" sz="1200" dirty="0">
+              <a:rPr lang="en-GB" sz="1100" dirty="0">
                 <a:latin typeface="Segoe UI" panose="020B0502040204020203" pitchFamily="34" charset="0"/>
                 <a:cs typeface="Segoe UI" panose="020B0502040204020203" pitchFamily="34" charset="0"/>
               </a:rPr>
@@ -3313,11 +3408,11 @@
               <a:buChar char="•"/>
             </a:pPr>
             <a:r>
-              <a:rPr lang="en-GB" sz="1200" dirty="0">
+              <a:rPr lang="en-GB" sz="1100" dirty="0">
                 <a:latin typeface="Segoe UI" panose="020B0502040204020203" pitchFamily="34" charset="0"/>
                 <a:cs typeface="Segoe UI" panose="020B0502040204020203" pitchFamily="34" charset="0"/>
               </a:rPr>
-              <a:t>Water Plants.</a:t>
+              <a:t>Water Plants (Water Conservation).</a:t>
             </a:r>
           </a:p>
           <a:p>
@@ -3326,7 +3421,7 @@
               <a:buChar char="•"/>
             </a:pPr>
             <a:r>
-              <a:rPr lang="en-GB" sz="1200" dirty="0">
+              <a:rPr lang="en-GB" sz="1100" dirty="0">
                 <a:latin typeface="Segoe UI" panose="020B0502040204020203" pitchFamily="34" charset="0"/>
                 <a:cs typeface="Segoe UI" panose="020B0502040204020203" pitchFamily="34" charset="0"/>
               </a:rPr>
@@ -3339,11 +3434,11 @@
               <a:buChar char="•"/>
             </a:pPr>
             <a:r>
-              <a:rPr lang="en-GB" sz="1200" dirty="0">
+              <a:rPr lang="en-GB" sz="1100" dirty="0">
                 <a:latin typeface="Segoe UI" panose="020B0502040204020203" pitchFamily="34" charset="0"/>
                 <a:cs typeface="Segoe UI" panose="020B0502040204020203" pitchFamily="34" charset="0"/>
               </a:rPr>
-              <a:t>Reliable (Works for Weeks / Months).</a:t>
+              <a:t>Reliable (Works for Months / Years).</a:t>
             </a:r>
           </a:p>
           <a:p>
@@ -3352,7 +3447,7 @@
               <a:buChar char="•"/>
             </a:pPr>
             <a:r>
-              <a:rPr lang="en-GB" sz="1200" dirty="0">
+              <a:rPr lang="en-GB" sz="1100" dirty="0">
                 <a:latin typeface="Segoe UI" panose="020B0502040204020203" pitchFamily="34" charset="0"/>
                 <a:cs typeface="Segoe UI" panose="020B0502040204020203" pitchFamily="34" charset="0"/>
               </a:rPr>
@@ -3365,11 +3460,11 @@
               <a:buChar char="•"/>
             </a:pPr>
             <a:r>
-              <a:rPr lang="en-GB" sz="1200" dirty="0">
+              <a:rPr lang="en-GB" sz="1100" dirty="0">
                 <a:latin typeface="Segoe UI" panose="020B0502040204020203" pitchFamily="34" charset="0"/>
                 <a:cs typeface="Segoe UI" panose="020B0502040204020203" pitchFamily="34" charset="0"/>
               </a:rPr>
-              <a:t>Relatively Cheap (&lt; ~£100).</a:t>
+              <a:t>Relatively Affordable (&lt; ~£100).</a:t>
             </a:r>
           </a:p>
           <a:p>
@@ -3378,7 +3473,20 @@
               <a:buChar char="•"/>
             </a:pPr>
             <a:r>
-              <a:rPr lang="en-GB" sz="1200" dirty="0">
+              <a:rPr lang="en-GB" sz="1100" dirty="0">
+                <a:latin typeface="Segoe UI" panose="020B0502040204020203" pitchFamily="34" charset="0"/>
+                <a:cs typeface="Segoe UI" panose="020B0502040204020203" pitchFamily="34" charset="0"/>
+              </a:rPr>
+              <a:t>A significant portion of this project has been research based as I have been ensuring it can fit my strict design brief with the main consideration being “Any Environment and Scale” because it increases the possible use cases to fit as many users needs as possible.</a:t>
+            </a:r>
+          </a:p>
+          <a:p>
+            <a:pPr marL="285750" indent="-285750">
+              <a:buFont typeface="Arial" panose="020B0604020202020204" pitchFamily="34" charset="0"/>
+              <a:buChar char="•"/>
+            </a:pPr>
+            <a:r>
+              <a:rPr lang="en-GB" sz="1100" dirty="0">
                 <a:latin typeface="Segoe UI" panose="020B0502040204020203" pitchFamily="34" charset="0"/>
                 <a:cs typeface="Segoe UI" panose="020B0502040204020203" pitchFamily="34" charset="0"/>
               </a:rPr>
@@ -3417,7 +3525,10 @@
           <a:p>
             <a:pPr algn="r"/>
             <a:r>
-              <a:rPr lang="en-GB" dirty="0"/>
+              <a:rPr lang="en-GB" dirty="0">
+                <a:latin typeface="Segoe UI" panose="020B0502040204020203" pitchFamily="34" charset="0"/>
+                <a:cs typeface="Segoe UI" panose="020B0502040204020203" pitchFamily="34" charset="0"/>
+              </a:rPr>
               <a:t>by Sam Dixon</a:t>
             </a:r>
           </a:p>
@@ -3461,7 +3572,7 @@
                 <a:latin typeface="Segoe UI" panose="020B0502040204020203" pitchFamily="34" charset="0"/>
                 <a:cs typeface="Segoe UI" panose="020B0502040204020203" pitchFamily="34" charset="0"/>
               </a:rPr>
-              <a:t>Circuit (Electronics)</a:t>
+              <a:t>Circuit - Electronic Engineering</a:t>
             </a:r>
           </a:p>
         </p:txBody>
@@ -3524,7 +3635,7 @@
         <p:spPr>
           <a:xfrm>
             <a:off x="9786759" y="1801514"/>
-            <a:ext cx="4858602" cy="1754326"/>
+            <a:ext cx="4858602" cy="2462213"/>
           </a:xfrm>
           <a:prstGeom prst="rect">
             <a:avLst/>
@@ -3542,11 +3653,11 @@
               <a:buChar char="•"/>
             </a:pPr>
             <a:r>
-              <a:rPr lang="en-GB" sz="1200" dirty="0">
+              <a:rPr lang="en-GB" sz="1100" dirty="0">
                 <a:latin typeface="Segoe UI" panose="020B0502040204020203" pitchFamily="34" charset="0"/>
                 <a:cs typeface="Segoe UI" panose="020B0502040204020203" pitchFamily="34" charset="0"/>
               </a:rPr>
-              <a:t>There will be a circuit in the command and switch modules which I will organise onto 2 custom PCBs that I will get produced by JLCPCB as it is very cheap and scalable for batch production.</a:t>
+              <a:t>There will be a circuit in the command and switch modules which I will organise onto 2 custom PCBs that I will get produced by JLCPCB as it is very cheap and scalable for batch production which I may consider if made into a product.</a:t>
             </a:r>
           </a:p>
           <a:p>
@@ -3555,11 +3666,11 @@
               <a:buChar char="•"/>
             </a:pPr>
             <a:r>
-              <a:rPr lang="en-GB" sz="1200" dirty="0">
+              <a:rPr lang="en-GB" sz="1100" dirty="0">
                 <a:latin typeface="Segoe UI" panose="020B0502040204020203" pitchFamily="34" charset="0"/>
                 <a:cs typeface="Segoe UI" panose="020B0502040204020203" pitchFamily="34" charset="0"/>
               </a:rPr>
-              <a:t>Command Module: Contains the microcontroller (ESP32) a temperature sensor, Wi-Fi switch, status LED and the power management (battery, solar).</a:t>
+              <a:t>Command Module which controls the entire system regulating all the valves and pumps at certain times contains: the microcontroller (ESP32), a temperature sensor, Wi-Fi switch, status LED and power management (battery, solar).</a:t>
             </a:r>
           </a:p>
           <a:p>
@@ -3568,11 +3679,11 @@
               <a:buChar char="•"/>
             </a:pPr>
             <a:r>
-              <a:rPr lang="en-GB" sz="1200" dirty="0">
+              <a:rPr lang="en-GB" sz="1100" dirty="0">
                 <a:latin typeface="Segoe UI" panose="020B0502040204020203" pitchFamily="34" charset="0"/>
                 <a:cs typeface="Segoe UI" panose="020B0502040204020203" pitchFamily="34" charset="0"/>
               </a:rPr>
-              <a:t>Switch Module: Contains shift register (74HC595) that will control relays (SRD-03VDC-SL-C) for each port.</a:t>
+              <a:t>Switch Module has multiple ports to turn on the valves and pumps bridging the gap between them and the command module containing: a shift register (74HC595) that will control relays (SRD-03VDC-SL-C) for each port.</a:t>
             </a:r>
           </a:p>
           <a:p>
@@ -3581,11 +3692,11 @@
               <a:buChar char="•"/>
             </a:pPr>
             <a:r>
-              <a:rPr lang="en-GB" sz="1200" dirty="0">
+              <a:rPr lang="en-GB" sz="1100" dirty="0">
                 <a:latin typeface="Segoe UI" panose="020B0502040204020203" pitchFamily="34" charset="0"/>
                 <a:cs typeface="Segoe UI" panose="020B0502040204020203" pitchFamily="34" charset="0"/>
               </a:rPr>
-              <a:t>Each module will have multiple ports (JST-PH) for power or data.</a:t>
+              <a:t>Each module will communicate using connectors (JST-PH) for power or data.</a:t>
             </a:r>
           </a:p>
         </p:txBody>
@@ -3604,7 +3715,7 @@
         </p:nvSpPr>
         <p:spPr>
           <a:xfrm>
-            <a:off x="9786759" y="5346969"/>
+            <a:off x="9786757" y="5964981"/>
             <a:ext cx="5196114" cy="461665"/>
           </a:xfrm>
           <a:prstGeom prst="rect">
@@ -3628,7 +3739,7 @@
                 <a:latin typeface="Segoe UI" panose="020B0502040204020203" pitchFamily="34" charset="0"/>
                 <a:cs typeface="Segoe UI" panose="020B0502040204020203" pitchFamily="34" charset="0"/>
               </a:rPr>
-              <a:t>Program (Regulation)</a:t>
+              <a:t>Regulation - Software Engineering</a:t>
             </a:r>
           </a:p>
         </p:txBody>
@@ -3649,7 +3760,7 @@
         </p:nvCxnSpPr>
         <p:spPr>
           <a:xfrm>
-            <a:off x="9786759" y="5808634"/>
+            <a:off x="9786757" y="6426646"/>
             <a:ext cx="4981431" cy="0"/>
           </a:xfrm>
           <a:prstGeom prst="line">
@@ -3690,8 +3801,8 @@
         </p:nvSpPr>
         <p:spPr>
           <a:xfrm>
-            <a:off x="9786759" y="5997546"/>
-            <a:ext cx="4858602" cy="2308324"/>
+            <a:off x="9786757" y="6615558"/>
+            <a:ext cx="4858602" cy="3985706"/>
           </a:xfrm>
           <a:prstGeom prst="rect">
             <a:avLst/>
@@ -3709,50 +3820,89 @@
               <a:buChar char="•"/>
             </a:pPr>
             <a:r>
-              <a:rPr lang="en-GB" sz="1200" dirty="0">
+              <a:rPr lang="en-GB" sz="1100" dirty="0">
                 <a:latin typeface="Segoe UI" panose="020B0502040204020203" pitchFamily="34" charset="0"/>
                 <a:cs typeface="Segoe UI" panose="020B0502040204020203" pitchFamily="34" charset="0"/>
               </a:rPr>
-              <a:t>The microcontroller (ESP32) will regulate the system with the program (C++ Code) running on it.</a:t>
-            </a:r>
-          </a:p>
-          <a:p>
-            <a:pPr marL="742950" lvl="1" indent="-285750">
+              <a:t>The microcontroller (ESP32) will control the entire system, regulating all the valves and pumps to ensure they turn on at the required times, with the program (C++ Code) running on it.</a:t>
+            </a:r>
+          </a:p>
+          <a:p>
+            <a:pPr marL="285750" indent="-285750">
               <a:buFont typeface="Arial" panose="020B0604020202020204" pitchFamily="34" charset="0"/>
               <a:buChar char="•"/>
             </a:pPr>
             <a:r>
-              <a:rPr lang="en-GB" sz="1200" dirty="0">
+              <a:rPr lang="en-GB" sz="1100" dirty="0">
                 <a:latin typeface="Segoe UI" panose="020B0502040204020203" pitchFamily="34" charset="0"/>
                 <a:cs typeface="Segoe UI" panose="020B0502040204020203" pitchFamily="34" charset="0"/>
               </a:rPr>
-              <a:t>It creates a Wi-Fi AP Network with a Web Server as well that users can connect to configure everything using the website interface.</a:t>
-            </a:r>
-          </a:p>
-          <a:p>
-            <a:pPr marL="742950" lvl="1" indent="-285750">
+              <a:t>It creates a Wi-Fi Access Point Network with a Web Server as well that users can connect to even in the most remote locations to configure everything using the website interface (on a phone / laptop).</a:t>
+            </a:r>
+          </a:p>
+          <a:p>
+            <a:pPr marL="285750" indent="-285750">
               <a:buFont typeface="Arial" panose="020B0604020202020204" pitchFamily="34" charset="0"/>
               <a:buChar char="•"/>
             </a:pPr>
             <a:r>
-              <a:rPr lang="en-GB" sz="1200" dirty="0">
+              <a:rPr lang="en-GB" sz="1100" dirty="0">
                 <a:latin typeface="Segoe UI" panose="020B0502040204020203" pitchFamily="34" charset="0"/>
                 <a:cs typeface="Segoe UI" panose="020B0502040204020203" pitchFamily="34" charset="0"/>
               </a:rPr>
-              <a:t>Routines can then be created that will turn on certain switch ports (Pumps / Valves) at certain times (12:00 every day or month) for a certain duration (60s).</a:t>
-            </a:r>
-          </a:p>
-          <a:p>
-            <a:pPr marL="742950" lvl="1" indent="-285750">
+              <a:t>Routines can then be created that will turn on certain switch ports (Pumps / Valves) at certain times (12:00 every day or month) for a certain duration (60s) to give full control allowing it to be used in any environment.</a:t>
+            </a:r>
+          </a:p>
+          <a:p>
+            <a:pPr marL="285750" indent="-285750">
               <a:buFont typeface="Arial" panose="020B0604020202020204" pitchFamily="34" charset="0"/>
               <a:buChar char="•"/>
             </a:pPr>
             <a:r>
-              <a:rPr lang="en-GB" sz="1200" dirty="0">
+              <a:rPr lang="en-GB" sz="1100" dirty="0">
                 <a:latin typeface="Segoe UI" panose="020B0502040204020203" pitchFamily="34" charset="0"/>
                 <a:cs typeface="Segoe UI" panose="020B0502040204020203" pitchFamily="34" charset="0"/>
               </a:rPr>
-              <a:t>This duration can be different depending on the temperature sensor: for instance, if its hot (summer) then give plants more water (120s) or if its cold (winter) then give plants little to no water (0s).</a:t>
+              <a:t>This duration can change depending on the temperature sensor, for instance, if its hot (summer) then give plants more water (120s) or if its cold (winter) then give plants little to no water (0s) to allow it to function reliably all year-round while also being sustainable as it is only using the water it needs.</a:t>
+            </a:r>
+          </a:p>
+          <a:p>
+            <a:pPr marL="285750" indent="-285750">
+              <a:buFont typeface="Arial" panose="020B0604020202020204" pitchFamily="34" charset="0"/>
+              <a:buChar char="•"/>
+            </a:pPr>
+            <a:r>
+              <a:rPr lang="en-GB" sz="1100" dirty="0">
+                <a:latin typeface="Segoe UI" panose="020B0502040204020203" pitchFamily="34" charset="0"/>
+                <a:cs typeface="Segoe UI" panose="020B0502040204020203" pitchFamily="34" charset="0"/>
+              </a:rPr>
+              <a:t>This ability to use only the water it needs to will allow it to conserve water used in times of shortage and still be able to function through hosepipe bans for instance that have happened recently in the UK.</a:t>
+            </a:r>
+          </a:p>
+          <a:p>
+            <a:pPr marL="285750" indent="-285750">
+              <a:buFont typeface="Arial" panose="020B0604020202020204" pitchFamily="34" charset="0"/>
+              <a:buChar char="•"/>
+            </a:pPr>
+            <a:r>
+              <a:rPr lang="en-GB" sz="1100" dirty="0">
+                <a:latin typeface="Segoe UI" panose="020B0502040204020203" pitchFamily="34" charset="0"/>
+                <a:cs typeface="Segoe UI" panose="020B0502040204020203" pitchFamily="34" charset="0"/>
+              </a:rPr>
+              <a:t>All this customisation is given through the simple website that anyone can use to alter the functionality for their personal needs.</a:t>
+            </a:r>
+          </a:p>
+          <a:p>
+            <a:pPr marL="285750" indent="-285750">
+              <a:buFont typeface="Arial" panose="020B0604020202020204" pitchFamily="34" charset="0"/>
+              <a:buChar char="•"/>
+            </a:pPr>
+            <a:r>
+              <a:rPr lang="en-GB" sz="1100" dirty="0">
+                <a:latin typeface="Segoe UI" panose="020B0502040204020203" pitchFamily="34" charset="0"/>
+                <a:cs typeface="Segoe UI" panose="020B0502040204020203" pitchFamily="34" charset="0"/>
+              </a:rPr>
+              <a:t>I believe this control for the user is very important as it really sets it apart from the alternatives which really lack any of this leading to the user being unsatisfied with their product which this solves.</a:t>
             </a:r>
           </a:p>
         </p:txBody>
@@ -3771,7 +3921,7 @@
         </p:nvSpPr>
         <p:spPr>
           <a:xfrm>
-            <a:off x="136479" y="5960743"/>
+            <a:off x="136005" y="5745298"/>
             <a:ext cx="5196114" cy="461665"/>
           </a:xfrm>
           <a:prstGeom prst="rect">
@@ -3795,7 +3945,7 @@
                 <a:latin typeface="Segoe UI" panose="020B0502040204020203" pitchFamily="34" charset="0"/>
                 <a:cs typeface="Segoe UI" panose="020B0502040204020203" pitchFamily="34" charset="0"/>
               </a:rPr>
-              <a:t>Model (CAD / 3D Print)</a:t>
+              <a:t>Model - Mechanical Engineering</a:t>
             </a:r>
           </a:p>
         </p:txBody>
@@ -3816,7 +3966,7 @@
         </p:nvCxnSpPr>
         <p:spPr>
           <a:xfrm>
-            <a:off x="136479" y="6422408"/>
+            <a:off x="136005" y="6206963"/>
             <a:ext cx="4981431" cy="0"/>
           </a:xfrm>
           <a:prstGeom prst="line">
@@ -3857,8 +4007,8 @@
         </p:nvSpPr>
         <p:spPr>
           <a:xfrm>
-            <a:off x="136479" y="6611320"/>
-            <a:ext cx="4858602" cy="3046988"/>
+            <a:off x="136005" y="6395875"/>
+            <a:ext cx="4858602" cy="3816429"/>
           </a:xfrm>
           <a:prstGeom prst="rect">
             <a:avLst/>
@@ -3876,11 +4026,11 @@
               <a:buChar char="•"/>
             </a:pPr>
             <a:r>
-              <a:rPr lang="en-GB" sz="1200" dirty="0">
+              <a:rPr lang="en-GB" sz="1100" dirty="0">
                 <a:latin typeface="Segoe UI" panose="020B0502040204020203" pitchFamily="34" charset="0"/>
                 <a:cs typeface="Segoe UI" panose="020B0502040204020203" pitchFamily="34" charset="0"/>
               </a:rPr>
-              <a:t>This design is built up of multiple modules to allow it to be scaled up from just a couple plants to hundreds with each being a 3D printed case that slide into each other on the sides.</a:t>
+              <a:t>This design is built up of multiple modules to allow it to be scaled up from just a couple plants to hundreds with each being a 3D printed (due to it being more cost effective) case that slide into each other on the sides.</a:t>
             </a:r>
           </a:p>
           <a:p>
@@ -3889,7 +4039,7 @@
               <a:buChar char="•"/>
             </a:pPr>
             <a:r>
-              <a:rPr lang="en-GB" sz="1200" dirty="0">
+              <a:rPr lang="en-GB" sz="1100" dirty="0">
                 <a:latin typeface="Segoe UI" panose="020B0502040204020203" pitchFamily="34" charset="0"/>
                 <a:cs typeface="Segoe UI" panose="020B0502040204020203" pitchFamily="34" charset="0"/>
               </a:rPr>
@@ -3902,7 +4052,7 @@
               <a:buChar char="•"/>
             </a:pPr>
             <a:r>
-              <a:rPr lang="en-GB" sz="1200" dirty="0">
+              <a:rPr lang="en-GB" sz="1100" dirty="0">
                 <a:latin typeface="Segoe UI" panose="020B0502040204020203" pitchFamily="34" charset="0"/>
                 <a:cs typeface="Segoe UI" panose="020B0502040204020203" pitchFamily="34" charset="0"/>
               </a:rPr>
@@ -3915,7 +4065,7 @@
               <a:buChar char="•"/>
             </a:pPr>
             <a:r>
-              <a:rPr lang="en-GB" sz="1200" dirty="0">
+              <a:rPr lang="en-GB" sz="1100" dirty="0">
                 <a:latin typeface="Segoe UI" panose="020B0502040204020203" pitchFamily="34" charset="0"/>
                 <a:cs typeface="Segoe UI" panose="020B0502040204020203" pitchFamily="34" charset="0"/>
               </a:rPr>
@@ -3928,77 +4078,28 @@
               <a:buChar char="•"/>
             </a:pPr>
             <a:r>
-              <a:rPr lang="en-GB" sz="1200" dirty="0">
+              <a:rPr lang="en-GB" sz="1100" dirty="0">
                 <a:latin typeface="Segoe UI" panose="020B0502040204020203" pitchFamily="34" charset="0"/>
                 <a:cs typeface="Segoe UI" panose="020B0502040204020203" pitchFamily="34" charset="0"/>
               </a:rPr>
-              <a:t>The Switch Modules control relays for ports to the valves or pumps when needed and can be chained together due to the switch registers inside to allow as many valves as possible and pumps to be added for the needed scale.</a:t>
-            </a:r>
-          </a:p>
-        </p:txBody>
-      </p:sp>
-      <p:pic>
-        <p:nvPicPr>
-          <p:cNvPr id="39" name="Picture 38">
-            <a:extLst>
-              <a:ext uri="{FF2B5EF4-FFF2-40B4-BE49-F238E27FC236}">
-                <a16:creationId xmlns:a16="http://schemas.microsoft.com/office/drawing/2014/main" id="{0645A90A-3B61-A55B-A875-0F389AA01EFD}"/>
-              </a:ext>
-            </a:extLst>
-          </p:cNvPr>
-          <p:cNvPicPr>
-            <a:picLocks noChangeAspect="1"/>
-          </p:cNvPicPr>
-          <p:nvPr/>
-        </p:nvPicPr>
-        <p:blipFill>
-          <a:blip r:embed="rId2"/>
-          <a:srcRect t="10144" b="14750"/>
-          <a:stretch>
-            <a:fillRect/>
-          </a:stretch>
-        </p:blipFill>
-        <p:spPr>
-          <a:xfrm>
-            <a:off x="4915612" y="3554554"/>
-            <a:ext cx="3742778" cy="4136433"/>
-          </a:xfrm>
-          <a:prstGeom prst="rect">
-            <a:avLst/>
-          </a:prstGeom>
-        </p:spPr>
-      </p:pic>
-      <p:pic>
-        <p:nvPicPr>
-          <p:cNvPr id="37" name="Picture 36">
-            <a:extLst>
-              <a:ext uri="{FF2B5EF4-FFF2-40B4-BE49-F238E27FC236}">
-                <a16:creationId xmlns:a16="http://schemas.microsoft.com/office/drawing/2014/main" id="{45620787-640E-A7DD-3B7E-36BCC53B3711}"/>
-              </a:ext>
-            </a:extLst>
-          </p:cNvPr>
-          <p:cNvPicPr>
-            <a:picLocks noChangeAspect="1"/>
-          </p:cNvPicPr>
-          <p:nvPr/>
-        </p:nvPicPr>
-        <p:blipFill>
-          <a:blip r:embed="rId3"/>
-          <a:srcRect l="9129" t="3624" r="4669" b="10944"/>
-          <a:stretch>
-            <a:fillRect/>
-          </a:stretch>
-        </p:blipFill>
-        <p:spPr>
-          <a:xfrm>
-            <a:off x="5371845" y="962023"/>
-            <a:ext cx="4375660" cy="2683186"/>
-          </a:xfrm>
-          <a:prstGeom prst="rect">
-            <a:avLst/>
-          </a:prstGeom>
-        </p:spPr>
-      </p:pic>
+              <a:t>The Switch Modules control relays for ports to the valves or pumps when needed and can be chained together due to the shift registers inside to allow as many valves and pumps as possible to be added for the required scale.</a:t>
+            </a:r>
+          </a:p>
+          <a:p>
+            <a:pPr marL="285750" indent="-285750">
+              <a:buFont typeface="Arial" panose="020B0604020202020204" pitchFamily="34" charset="0"/>
+              <a:buChar char="•"/>
+            </a:pPr>
+            <a:r>
+              <a:rPr lang="en-GB" sz="1100" dirty="0">
+                <a:latin typeface="Segoe UI" panose="020B0502040204020203" pitchFamily="34" charset="0"/>
+                <a:cs typeface="Segoe UI" panose="020B0502040204020203" pitchFamily="34" charset="0"/>
+              </a:rPr>
+              <a:t>An example of an application of this project would be in a greenhouse where the plants on one side need to get more water (due to sunlight) that the other so could be on a different valve port meaning one side has it open for longer than the other allowing full control for the user over their plants or crops (same principle could be applied to a farm).</a:t>
+            </a:r>
+          </a:p>
+        </p:txBody>
+      </p:sp>
       <p:sp>
         <p:nvSpPr>
           <p:cNvPr id="42" name="Rectangle: Diagonal Corners Snipped 41">
@@ -4013,7 +4114,7 @@
         </p:nvSpPr>
         <p:spPr>
           <a:xfrm>
-            <a:off x="8808073" y="3787502"/>
+            <a:off x="8808073" y="4464114"/>
             <a:ext cx="1007227" cy="258794"/>
           </a:xfrm>
           <a:prstGeom prst="snip2DiagRect">
@@ -4050,6 +4151,8 @@
                     <a:lumMod val="25000"/>
                   </a:schemeClr>
                 </a:solidFill>
+                <a:latin typeface="Segoe UI" panose="020B0502040204020203" pitchFamily="34" charset="0"/>
+                <a:cs typeface="Segoe UI" panose="020B0502040204020203" pitchFamily="34" charset="0"/>
               </a:rPr>
               <a:t>Temp Sensor</a:t>
             </a:r>
@@ -4070,7 +4173,7 @@
         </p:nvSpPr>
         <p:spPr>
           <a:xfrm>
-            <a:off x="8808074" y="4164901"/>
+            <a:off x="8808074" y="4841513"/>
             <a:ext cx="1007227" cy="258794"/>
           </a:xfrm>
           <a:prstGeom prst="snip2DiagRect">
@@ -4107,6 +4210,8 @@
                     <a:lumMod val="25000"/>
                   </a:schemeClr>
                 </a:solidFill>
+                <a:latin typeface="Segoe UI" panose="020B0502040204020203" pitchFamily="34" charset="0"/>
+                <a:cs typeface="Segoe UI" panose="020B0502040204020203" pitchFamily="34" charset="0"/>
               </a:rPr>
               <a:t>Wi-Fi Switch</a:t>
             </a:r>
@@ -4127,7 +4232,7 @@
         </p:nvSpPr>
         <p:spPr>
           <a:xfrm>
-            <a:off x="8808073" y="4542300"/>
+            <a:off x="8808073" y="5218912"/>
             <a:ext cx="1007227" cy="258794"/>
           </a:xfrm>
           <a:prstGeom prst="snip2DiagRect">
@@ -4164,6 +4269,8 @@
                     <a:lumMod val="25000"/>
                   </a:schemeClr>
                 </a:solidFill>
+                <a:latin typeface="Segoe UI" panose="020B0502040204020203" pitchFamily="34" charset="0"/>
+                <a:cs typeface="Segoe UI" panose="020B0502040204020203" pitchFamily="34" charset="0"/>
               </a:rPr>
               <a:t>Status LED </a:t>
             </a:r>
@@ -4188,7 +4295,7 @@
         </p:nvCxnSpPr>
         <p:spPr>
           <a:xfrm>
-            <a:off x="9815300" y="3916899"/>
+            <a:off x="9815300" y="4593511"/>
             <a:ext cx="375535" cy="179755"/>
           </a:xfrm>
           <a:prstGeom prst="bentConnector3">
@@ -4236,7 +4343,7 @@
         </p:nvCxnSpPr>
         <p:spPr>
           <a:xfrm flipV="1">
-            <a:off x="9815301" y="4096654"/>
+            <a:off x="9815301" y="4773266"/>
             <a:ext cx="375534" cy="197644"/>
           </a:xfrm>
           <a:prstGeom prst="bentConnector3">
@@ -4284,7 +4391,7 @@
         </p:nvCxnSpPr>
         <p:spPr>
           <a:xfrm rot="5400000">
-            <a:off x="10071983" y="4049230"/>
+            <a:off x="10071983" y="4725842"/>
             <a:ext cx="365785" cy="879149"/>
           </a:xfrm>
           <a:prstGeom prst="bentConnector2">
@@ -4330,7 +4437,7 @@
         </p:nvCxnSpPr>
         <p:spPr>
           <a:xfrm>
-            <a:off x="11452223" y="3744811"/>
+            <a:off x="11452223" y="4421423"/>
             <a:ext cx="474" cy="1416614"/>
           </a:xfrm>
           <a:prstGeom prst="line">
@@ -4372,7 +4479,7 @@
         </p:nvSpPr>
         <p:spPr>
           <a:xfrm>
-            <a:off x="10190835" y="3887395"/>
+            <a:off x="10190835" y="4564007"/>
             <a:ext cx="1007227" cy="418517"/>
           </a:xfrm>
           <a:prstGeom prst="snip2DiagRect">
@@ -4409,6 +4516,8 @@
                     <a:lumMod val="25000"/>
                   </a:schemeClr>
                 </a:solidFill>
+                <a:latin typeface="Segoe UI" panose="020B0502040204020203" pitchFamily="34" charset="0"/>
+                <a:cs typeface="Segoe UI" panose="020B0502040204020203" pitchFamily="34" charset="0"/>
               </a:rPr>
               <a:t>ESP32 (MC)</a:t>
             </a:r>
@@ -4429,7 +4538,7 @@
         </p:nvSpPr>
         <p:spPr>
           <a:xfrm>
-            <a:off x="11707332" y="3969710"/>
+            <a:off x="11707332" y="4646322"/>
             <a:ext cx="1007227" cy="258794"/>
           </a:xfrm>
           <a:prstGeom prst="snip2DiagRect">
@@ -4466,6 +4575,8 @@
                     <a:lumMod val="25000"/>
                   </a:schemeClr>
                 </a:solidFill>
+                <a:latin typeface="Segoe UI" panose="020B0502040204020203" pitchFamily="34" charset="0"/>
+                <a:cs typeface="Segoe UI" panose="020B0502040204020203" pitchFamily="34" charset="0"/>
               </a:rPr>
               <a:t>Shift Register</a:t>
             </a:r>
@@ -4486,7 +4597,7 @@
         </p:nvSpPr>
         <p:spPr>
           <a:xfrm>
-            <a:off x="13002632" y="4047119"/>
+            <a:off x="13002632" y="4723731"/>
             <a:ext cx="707308" cy="258794"/>
           </a:xfrm>
           <a:prstGeom prst="snip2DiagRect">
@@ -4523,6 +4634,8 @@
                     <a:lumMod val="25000"/>
                   </a:schemeClr>
                 </a:solidFill>
+                <a:latin typeface="Segoe UI" panose="020B0502040204020203" pitchFamily="34" charset="0"/>
+                <a:cs typeface="Segoe UI" panose="020B0502040204020203" pitchFamily="34" charset="0"/>
               </a:rPr>
               <a:t>Relay</a:t>
             </a:r>
@@ -4543,7 +4656,7 @@
         </p:nvSpPr>
         <p:spPr>
           <a:xfrm>
-            <a:off x="12998876" y="4404808"/>
+            <a:off x="12998876" y="5081420"/>
             <a:ext cx="707308" cy="258794"/>
           </a:xfrm>
           <a:prstGeom prst="snip2DiagRect">
@@ -4580,6 +4693,8 @@
                     <a:lumMod val="25000"/>
                   </a:schemeClr>
                 </a:solidFill>
+                <a:latin typeface="Segoe UI" panose="020B0502040204020203" pitchFamily="34" charset="0"/>
+                <a:cs typeface="Segoe UI" panose="020B0502040204020203" pitchFamily="34" charset="0"/>
               </a:rPr>
               <a:t>Relay</a:t>
             </a:r>
@@ -4600,7 +4715,7 @@
         </p:nvSpPr>
         <p:spPr>
           <a:xfrm>
-            <a:off x="12996268" y="4564291"/>
+            <a:off x="13005701" y="5256460"/>
             <a:ext cx="707307" cy="276999"/>
           </a:xfrm>
           <a:prstGeom prst="rect">
@@ -4616,7 +4731,10 @@
           <a:p>
             <a:pPr algn="ctr"/>
             <a:r>
-              <a:rPr lang="en-GB" sz="1200" dirty="0"/>
+              <a:rPr lang="en-GB" sz="1200" dirty="0">
+                <a:latin typeface="Segoe UI" panose="020B0502040204020203" pitchFamily="34" charset="0"/>
+                <a:cs typeface="Segoe UI" panose="020B0502040204020203" pitchFamily="34" charset="0"/>
+              </a:rPr>
               <a:t>…</a:t>
             </a:r>
           </a:p>
@@ -4640,7 +4758,7 @@
         </p:nvCxnSpPr>
         <p:spPr>
           <a:xfrm>
-            <a:off x="12714559" y="4099107"/>
+            <a:off x="12714559" y="4775719"/>
             <a:ext cx="288073" cy="77409"/>
           </a:xfrm>
           <a:prstGeom prst="bentConnector3">
@@ -4690,7 +4808,7 @@
         </p:nvCxnSpPr>
         <p:spPr>
           <a:xfrm>
-            <a:off x="12714559" y="4099107"/>
+            <a:off x="12714559" y="4775719"/>
             <a:ext cx="284317" cy="435098"/>
           </a:xfrm>
           <a:prstGeom prst="bentConnector3">
@@ -4738,7 +4856,7 @@
         </p:nvCxnSpPr>
         <p:spPr>
           <a:xfrm>
-            <a:off x="13966823" y="3744751"/>
+            <a:off x="13966823" y="4421363"/>
             <a:ext cx="0" cy="1416674"/>
           </a:xfrm>
           <a:prstGeom prst="line">
@@ -4780,7 +4898,7 @@
         </p:nvSpPr>
         <p:spPr>
           <a:xfrm>
-            <a:off x="14223707" y="4137811"/>
+            <a:off x="14223707" y="4814423"/>
             <a:ext cx="707308" cy="258794"/>
           </a:xfrm>
           <a:prstGeom prst="snip2DiagRect">
@@ -4817,6 +4935,8 @@
                     <a:lumMod val="25000"/>
                   </a:schemeClr>
                 </a:solidFill>
+                <a:latin typeface="Segoe UI" panose="020B0502040204020203" pitchFamily="34" charset="0"/>
+                <a:cs typeface="Segoe UI" panose="020B0502040204020203" pitchFamily="34" charset="0"/>
               </a:rPr>
               <a:t>Valve</a:t>
             </a:r>
@@ -4837,7 +4957,7 @@
         </p:nvSpPr>
         <p:spPr>
           <a:xfrm>
-            <a:off x="14223707" y="4490844"/>
+            <a:off x="14223707" y="5167456"/>
             <a:ext cx="707308" cy="258794"/>
           </a:xfrm>
           <a:prstGeom prst="snip2DiagRect">
@@ -4874,6 +4994,8 @@
                     <a:lumMod val="25000"/>
                   </a:schemeClr>
                 </a:solidFill>
+                <a:latin typeface="Segoe UI" panose="020B0502040204020203" pitchFamily="34" charset="0"/>
+                <a:cs typeface="Segoe UI" panose="020B0502040204020203" pitchFamily="34" charset="0"/>
               </a:rPr>
               <a:t>Pump</a:t>
             </a:r>
@@ -4894,7 +5016,7 @@
         </p:nvSpPr>
         <p:spPr>
           <a:xfrm>
-            <a:off x="14220639" y="4640099"/>
+            <a:off x="14220639" y="5347264"/>
             <a:ext cx="707307" cy="276999"/>
           </a:xfrm>
           <a:prstGeom prst="rect">
@@ -4910,7 +5032,10 @@
           <a:p>
             <a:pPr algn="ctr"/>
             <a:r>
-              <a:rPr lang="en-GB" sz="1200" dirty="0"/>
+              <a:rPr lang="en-GB" sz="1200" dirty="0">
+                <a:latin typeface="Segoe UI" panose="020B0502040204020203" pitchFamily="34" charset="0"/>
+                <a:cs typeface="Segoe UI" panose="020B0502040204020203" pitchFamily="34" charset="0"/>
+              </a:rPr>
               <a:t>…</a:t>
             </a:r>
           </a:p>
@@ -4934,7 +5059,7 @@
         </p:nvCxnSpPr>
         <p:spPr>
           <a:xfrm>
-            <a:off x="13709940" y="4176516"/>
+            <a:off x="13709940" y="4853128"/>
             <a:ext cx="513767" cy="90692"/>
           </a:xfrm>
           <a:prstGeom prst="bentConnector3">
@@ -4984,7 +5109,7 @@
         </p:nvCxnSpPr>
         <p:spPr>
           <a:xfrm>
-            <a:off x="13706184" y="4534205"/>
+            <a:off x="13706184" y="5210817"/>
             <a:ext cx="517523" cy="86036"/>
           </a:xfrm>
           <a:prstGeom prst="bentConnector3">
@@ -5030,7 +5155,7 @@
         </p:nvSpPr>
         <p:spPr>
           <a:xfrm>
-            <a:off x="11596379" y="4644881"/>
+            <a:off x="11596379" y="5321493"/>
             <a:ext cx="1007227" cy="258794"/>
           </a:xfrm>
           <a:prstGeom prst="snip2DiagRect">
@@ -5067,6 +5192,8 @@
                     <a:lumMod val="25000"/>
                   </a:schemeClr>
                 </a:solidFill>
+                <a:latin typeface="Segoe UI" panose="020B0502040204020203" pitchFamily="34" charset="0"/>
+                <a:cs typeface="Segoe UI" panose="020B0502040204020203" pitchFamily="34" charset="0"/>
               </a:rPr>
               <a:t>Shift Register</a:t>
             </a:r>
@@ -5091,7 +5218,7 @@
         </p:nvCxnSpPr>
         <p:spPr>
           <a:xfrm rot="5400000">
-            <a:off x="11947282" y="4381216"/>
+            <a:off x="11947282" y="5057828"/>
             <a:ext cx="416377" cy="110953"/>
           </a:xfrm>
           <a:prstGeom prst="bentConnector3">
@@ -5137,7 +5264,7 @@
         </p:nvSpPr>
         <p:spPr>
           <a:xfrm>
-            <a:off x="11599450" y="4801094"/>
+            <a:off x="11599450" y="5516994"/>
             <a:ext cx="1007223" cy="276999"/>
           </a:xfrm>
           <a:prstGeom prst="rect">
@@ -5153,7 +5280,10 @@
           <a:p>
             <a:pPr algn="ctr"/>
             <a:r>
-              <a:rPr lang="en-GB" sz="1200" dirty="0"/>
+              <a:rPr lang="en-GB" sz="1200" dirty="0">
+                <a:latin typeface="Segoe UI" panose="020B0502040204020203" pitchFamily="34" charset="0"/>
+                <a:cs typeface="Segoe UI" panose="020B0502040204020203" pitchFamily="34" charset="0"/>
+              </a:rPr>
               <a:t>…</a:t>
             </a:r>
           </a:p>
@@ -5177,7 +5307,7 @@
         </p:nvCxnSpPr>
         <p:spPr>
           <a:xfrm>
-            <a:off x="11198062" y="4096654"/>
+            <a:off x="11198062" y="4773266"/>
             <a:ext cx="509270" cy="2453"/>
           </a:xfrm>
           <a:prstGeom prst="straightConnector1">
@@ -5209,775 +5339,6 @@
       </p:cxnSp>
       <p:sp>
         <p:nvSpPr>
-          <p:cNvPr id="139" name="Rectangle: Diagonal Corners Snipped 138">
-            <a:extLst>
-              <a:ext uri="{FF2B5EF4-FFF2-40B4-BE49-F238E27FC236}">
-                <a16:creationId xmlns:a16="http://schemas.microsoft.com/office/drawing/2014/main" id="{72B4694D-A0F0-A547-DB86-9A2593AF61AD}"/>
-              </a:ext>
-            </a:extLst>
-          </p:cNvPr>
-          <p:cNvSpPr/>
-          <p:nvPr/>
-        </p:nvSpPr>
-        <p:spPr>
-          <a:xfrm>
-            <a:off x="9794258" y="9456508"/>
-            <a:ext cx="1007227" cy="418517"/>
-          </a:xfrm>
-          <a:prstGeom prst="snip2DiagRect">
-            <a:avLst/>
-          </a:prstGeom>
-          <a:noFill/>
-          <a:ln w="6350"/>
-        </p:spPr>
-        <p:style>
-          <a:lnRef idx="2">
-            <a:schemeClr val="accent1">
-              <a:shade val="15000"/>
-            </a:schemeClr>
-          </a:lnRef>
-          <a:fillRef idx="1">
-            <a:schemeClr val="accent1"/>
-          </a:fillRef>
-          <a:effectRef idx="0">
-            <a:schemeClr val="accent1"/>
-          </a:effectRef>
-          <a:fontRef idx="minor">
-            <a:schemeClr val="lt1"/>
-          </a:fontRef>
-        </p:style>
-        <p:txBody>
-          <a:bodyPr rtlCol="0" anchor="ctr"/>
-          <a:lstStyle/>
-          <a:p>
-            <a:pPr algn="ctr"/>
-            <a:r>
-              <a:rPr lang="en-GB" sz="1050" dirty="0">
-                <a:solidFill>
-                  <a:schemeClr val="bg2">
-                    <a:lumMod val="25000"/>
-                  </a:schemeClr>
-                </a:solidFill>
-              </a:rPr>
-              <a:t>Program Flow</a:t>
-            </a:r>
-          </a:p>
-        </p:txBody>
-      </p:sp>
-      <p:sp>
-        <p:nvSpPr>
-          <p:cNvPr id="140" name="Rectangle: Diagonal Corners Snipped 139">
-            <a:extLst>
-              <a:ext uri="{FF2B5EF4-FFF2-40B4-BE49-F238E27FC236}">
-                <a16:creationId xmlns:a16="http://schemas.microsoft.com/office/drawing/2014/main" id="{0676AE62-DA92-D7CC-32B3-E4E721C07E74}"/>
-              </a:ext>
-            </a:extLst>
-          </p:cNvPr>
-          <p:cNvSpPr/>
-          <p:nvPr/>
-        </p:nvSpPr>
-        <p:spPr>
-          <a:xfrm>
-            <a:off x="9794258" y="9007051"/>
-            <a:ext cx="1007227" cy="258794"/>
-          </a:xfrm>
-          <a:prstGeom prst="snip2DiagRect">
-            <a:avLst/>
-          </a:prstGeom>
-          <a:noFill/>
-          <a:ln w="6350"/>
-        </p:spPr>
-        <p:style>
-          <a:lnRef idx="2">
-            <a:schemeClr val="accent1">
-              <a:shade val="15000"/>
-            </a:schemeClr>
-          </a:lnRef>
-          <a:fillRef idx="1">
-            <a:schemeClr val="accent1"/>
-          </a:fillRef>
-          <a:effectRef idx="0">
-            <a:schemeClr val="accent1"/>
-          </a:effectRef>
-          <a:fontRef idx="minor">
-            <a:schemeClr val="lt1"/>
-          </a:fontRef>
-        </p:style>
-        <p:txBody>
-          <a:bodyPr rtlCol="0" anchor="ctr"/>
-          <a:lstStyle/>
-          <a:p>
-            <a:pPr algn="ctr"/>
-            <a:r>
-              <a:rPr lang="en-GB" sz="1050" dirty="0">
-                <a:solidFill>
-                  <a:schemeClr val="bg2">
-                    <a:lumMod val="25000"/>
-                  </a:schemeClr>
-                </a:solidFill>
-              </a:rPr>
-              <a:t>Wi-Fi</a:t>
-            </a:r>
-          </a:p>
-        </p:txBody>
-      </p:sp>
-      <p:sp>
-        <p:nvSpPr>
-          <p:cNvPr id="141" name="Rectangle: Diagonal Corners Snipped 140">
-            <a:extLst>
-              <a:ext uri="{FF2B5EF4-FFF2-40B4-BE49-F238E27FC236}">
-                <a16:creationId xmlns:a16="http://schemas.microsoft.com/office/drawing/2014/main" id="{1D22AD3D-3934-5C8C-AF7D-72CF3269236A}"/>
-              </a:ext>
-            </a:extLst>
-          </p:cNvPr>
-          <p:cNvSpPr/>
-          <p:nvPr/>
-        </p:nvSpPr>
-        <p:spPr>
-          <a:xfrm>
-            <a:off x="9786759" y="8558634"/>
-            <a:ext cx="1007227" cy="258794"/>
-          </a:xfrm>
-          <a:prstGeom prst="snip2DiagRect">
-            <a:avLst/>
-          </a:prstGeom>
-          <a:noFill/>
-          <a:ln w="6350"/>
-        </p:spPr>
-        <p:style>
-          <a:lnRef idx="2">
-            <a:schemeClr val="accent1">
-              <a:shade val="15000"/>
-            </a:schemeClr>
-          </a:lnRef>
-          <a:fillRef idx="1">
-            <a:schemeClr val="accent1"/>
-          </a:fillRef>
-          <a:effectRef idx="0">
-            <a:schemeClr val="accent1"/>
-          </a:effectRef>
-          <a:fontRef idx="minor">
-            <a:schemeClr val="lt1"/>
-          </a:fontRef>
-        </p:style>
-        <p:txBody>
-          <a:bodyPr rtlCol="0" anchor="ctr"/>
-          <a:lstStyle/>
-          <a:p>
-            <a:pPr algn="ctr"/>
-            <a:r>
-              <a:rPr lang="en-GB" sz="1050" dirty="0">
-                <a:solidFill>
-                  <a:schemeClr val="bg2">
-                    <a:lumMod val="25000"/>
-                  </a:schemeClr>
-                </a:solidFill>
-              </a:rPr>
-              <a:t>Website</a:t>
-            </a:r>
-          </a:p>
-        </p:txBody>
-      </p:sp>
-      <p:sp>
-        <p:nvSpPr>
-          <p:cNvPr id="142" name="Rectangle: Diagonal Corners Snipped 141">
-            <a:extLst>
-              <a:ext uri="{FF2B5EF4-FFF2-40B4-BE49-F238E27FC236}">
-                <a16:creationId xmlns:a16="http://schemas.microsoft.com/office/drawing/2014/main" id="{72F93AA0-2CA5-C2FD-25F2-0E329E5E5EFB}"/>
-              </a:ext>
-            </a:extLst>
-          </p:cNvPr>
-          <p:cNvSpPr/>
-          <p:nvPr/>
-        </p:nvSpPr>
-        <p:spPr>
-          <a:xfrm>
-            <a:off x="11203473" y="8558634"/>
-            <a:ext cx="784748" cy="258794"/>
-          </a:xfrm>
-          <a:prstGeom prst="snip2DiagRect">
-            <a:avLst/>
-          </a:prstGeom>
-          <a:noFill/>
-          <a:ln w="6350"/>
-        </p:spPr>
-        <p:style>
-          <a:lnRef idx="2">
-            <a:schemeClr val="accent1">
-              <a:shade val="15000"/>
-            </a:schemeClr>
-          </a:lnRef>
-          <a:fillRef idx="1">
-            <a:schemeClr val="accent1"/>
-          </a:fillRef>
-          <a:effectRef idx="0">
-            <a:schemeClr val="accent1"/>
-          </a:effectRef>
-          <a:fontRef idx="minor">
-            <a:schemeClr val="lt1"/>
-          </a:fontRef>
-        </p:style>
-        <p:txBody>
-          <a:bodyPr rtlCol="0" anchor="ctr"/>
-          <a:lstStyle/>
-          <a:p>
-            <a:pPr algn="ctr"/>
-            <a:r>
-              <a:rPr lang="en-GB" sz="1050" dirty="0">
-                <a:solidFill>
-                  <a:schemeClr val="bg2">
-                    <a:lumMod val="25000"/>
-                  </a:schemeClr>
-                </a:solidFill>
-              </a:rPr>
-              <a:t>Config</a:t>
-            </a:r>
-          </a:p>
-        </p:txBody>
-      </p:sp>
-      <p:sp>
-        <p:nvSpPr>
-          <p:cNvPr id="146" name="Rectangle: Diagonal Corners Snipped 145">
-            <a:extLst>
-              <a:ext uri="{FF2B5EF4-FFF2-40B4-BE49-F238E27FC236}">
-                <a16:creationId xmlns:a16="http://schemas.microsoft.com/office/drawing/2014/main" id="{A7D8302D-FEDB-FEFC-4BCA-BDB02D892536}"/>
-              </a:ext>
-            </a:extLst>
-          </p:cNvPr>
-          <p:cNvSpPr/>
-          <p:nvPr/>
-        </p:nvSpPr>
-        <p:spPr>
-          <a:xfrm>
-            <a:off x="11222702" y="9536370"/>
-            <a:ext cx="765519" cy="258794"/>
-          </a:xfrm>
-          <a:prstGeom prst="snip2DiagRect">
-            <a:avLst/>
-          </a:prstGeom>
-          <a:noFill/>
-          <a:ln w="6350"/>
-        </p:spPr>
-        <p:style>
-          <a:lnRef idx="2">
-            <a:schemeClr val="accent1">
-              <a:shade val="15000"/>
-            </a:schemeClr>
-          </a:lnRef>
-          <a:fillRef idx="1">
-            <a:schemeClr val="accent1"/>
-          </a:fillRef>
-          <a:effectRef idx="0">
-            <a:schemeClr val="accent1"/>
-          </a:effectRef>
-          <a:fontRef idx="minor">
-            <a:schemeClr val="lt1"/>
-          </a:fontRef>
-        </p:style>
-        <p:txBody>
-          <a:bodyPr rtlCol="0" anchor="ctr"/>
-          <a:lstStyle/>
-          <a:p>
-            <a:pPr algn="ctr"/>
-            <a:r>
-              <a:rPr lang="en-GB" sz="1050" dirty="0">
-                <a:solidFill>
-                  <a:schemeClr val="bg2">
-                    <a:lumMod val="25000"/>
-                  </a:schemeClr>
-                </a:solidFill>
-              </a:rPr>
-              <a:t>Routines</a:t>
-            </a:r>
-          </a:p>
-        </p:txBody>
-      </p:sp>
-      <p:sp>
-        <p:nvSpPr>
-          <p:cNvPr id="148" name="Rectangle: Diagonal Corners Snipped 147">
-            <a:extLst>
-              <a:ext uri="{FF2B5EF4-FFF2-40B4-BE49-F238E27FC236}">
-                <a16:creationId xmlns:a16="http://schemas.microsoft.com/office/drawing/2014/main" id="{DE0F1C8D-AF5B-38C4-87AD-2D6E2409D5F1}"/>
-              </a:ext>
-            </a:extLst>
-          </p:cNvPr>
-          <p:cNvSpPr/>
-          <p:nvPr/>
-        </p:nvSpPr>
-        <p:spPr>
-          <a:xfrm>
-            <a:off x="9794258" y="10065688"/>
-            <a:ext cx="1007227" cy="258794"/>
-          </a:xfrm>
-          <a:prstGeom prst="snip2DiagRect">
-            <a:avLst/>
-          </a:prstGeom>
-          <a:noFill/>
-          <a:ln w="6350"/>
-        </p:spPr>
-        <p:style>
-          <a:lnRef idx="2">
-            <a:schemeClr val="accent1">
-              <a:shade val="15000"/>
-            </a:schemeClr>
-          </a:lnRef>
-          <a:fillRef idx="1">
-            <a:schemeClr val="accent1"/>
-          </a:fillRef>
-          <a:effectRef idx="0">
-            <a:schemeClr val="accent1"/>
-          </a:effectRef>
-          <a:fontRef idx="minor">
-            <a:schemeClr val="lt1"/>
-          </a:fontRef>
-        </p:style>
-        <p:txBody>
-          <a:bodyPr rtlCol="0" anchor="ctr"/>
-          <a:lstStyle/>
-          <a:p>
-            <a:pPr algn="ctr"/>
-            <a:r>
-              <a:rPr lang="en-GB" sz="1050" dirty="0">
-                <a:solidFill>
-                  <a:schemeClr val="bg2">
-                    <a:lumMod val="25000"/>
-                  </a:schemeClr>
-                </a:solidFill>
-              </a:rPr>
-              <a:t>Time</a:t>
-            </a:r>
-          </a:p>
-        </p:txBody>
-      </p:sp>
-      <p:cxnSp>
-        <p:nvCxnSpPr>
-          <p:cNvPr id="150" name="Straight Arrow Connector 149">
-            <a:extLst>
-              <a:ext uri="{FF2B5EF4-FFF2-40B4-BE49-F238E27FC236}">
-                <a16:creationId xmlns:a16="http://schemas.microsoft.com/office/drawing/2014/main" id="{D1A4C853-8BF1-1430-4F1A-1B1BB687ED01}"/>
-              </a:ext>
-            </a:extLst>
-          </p:cNvPr>
-          <p:cNvCxnSpPr>
-            <a:cxnSpLocks/>
-            <a:stCxn id="139" idx="3"/>
-            <a:endCxn id="140" idx="1"/>
-          </p:cNvCxnSpPr>
-          <p:nvPr/>
-        </p:nvCxnSpPr>
-        <p:spPr>
-          <a:xfrm flipV="1">
-            <a:off x="10297872" y="9265845"/>
-            <a:ext cx="0" cy="190663"/>
-          </a:xfrm>
-          <a:prstGeom prst="straightConnector1">
-            <a:avLst/>
-          </a:prstGeom>
-          <a:ln>
-            <a:solidFill>
-              <a:schemeClr val="bg2">
-                <a:lumMod val="25000"/>
-              </a:schemeClr>
-            </a:solidFill>
-            <a:headEnd type="triangle"/>
-            <a:tailEnd type="triangle"/>
-          </a:ln>
-        </p:spPr>
-        <p:style>
-          <a:lnRef idx="2">
-            <a:schemeClr val="accent1"/>
-          </a:lnRef>
-          <a:fillRef idx="0">
-            <a:schemeClr val="accent1"/>
-          </a:fillRef>
-          <a:effectRef idx="1">
-            <a:schemeClr val="accent1"/>
-          </a:effectRef>
-          <a:fontRef idx="minor">
-            <a:schemeClr val="tx1"/>
-          </a:fontRef>
-        </p:style>
-      </p:cxnSp>
-      <p:cxnSp>
-        <p:nvCxnSpPr>
-          <p:cNvPr id="152" name="Straight Arrow Connector 151">
-            <a:extLst>
-              <a:ext uri="{FF2B5EF4-FFF2-40B4-BE49-F238E27FC236}">
-                <a16:creationId xmlns:a16="http://schemas.microsoft.com/office/drawing/2014/main" id="{5082FB55-092E-1F8A-4BCC-E7BD0445D793}"/>
-              </a:ext>
-            </a:extLst>
-          </p:cNvPr>
-          <p:cNvCxnSpPr>
-            <a:cxnSpLocks/>
-            <a:stCxn id="140" idx="3"/>
-            <a:endCxn id="141" idx="1"/>
-          </p:cNvCxnSpPr>
-          <p:nvPr/>
-        </p:nvCxnSpPr>
-        <p:spPr>
-          <a:xfrm flipH="1" flipV="1">
-            <a:off x="10290373" y="8817428"/>
-            <a:ext cx="7499" cy="189623"/>
-          </a:xfrm>
-          <a:prstGeom prst="straightConnector1">
-            <a:avLst/>
-          </a:prstGeom>
-          <a:ln>
-            <a:solidFill>
-              <a:schemeClr val="bg2">
-                <a:lumMod val="25000"/>
-              </a:schemeClr>
-            </a:solidFill>
-            <a:headEnd type="triangle"/>
-            <a:tailEnd type="triangle"/>
-          </a:ln>
-        </p:spPr>
-        <p:style>
-          <a:lnRef idx="2">
-            <a:schemeClr val="accent1"/>
-          </a:lnRef>
-          <a:fillRef idx="0">
-            <a:schemeClr val="accent1"/>
-          </a:fillRef>
-          <a:effectRef idx="1">
-            <a:schemeClr val="accent1"/>
-          </a:effectRef>
-          <a:fontRef idx="minor">
-            <a:schemeClr val="tx1"/>
-          </a:fontRef>
-        </p:style>
-      </p:cxnSp>
-      <p:cxnSp>
-        <p:nvCxnSpPr>
-          <p:cNvPr id="157" name="Straight Arrow Connector 156">
-            <a:extLst>
-              <a:ext uri="{FF2B5EF4-FFF2-40B4-BE49-F238E27FC236}">
-                <a16:creationId xmlns:a16="http://schemas.microsoft.com/office/drawing/2014/main" id="{1F74BBC7-6FDE-A6C3-CAA3-E019B53BA2B0}"/>
-              </a:ext>
-            </a:extLst>
-          </p:cNvPr>
-          <p:cNvCxnSpPr>
-            <a:cxnSpLocks/>
-            <a:stCxn id="142" idx="2"/>
-            <a:endCxn id="141" idx="0"/>
-          </p:cNvCxnSpPr>
-          <p:nvPr/>
-        </p:nvCxnSpPr>
-        <p:spPr>
-          <a:xfrm flipH="1">
-            <a:off x="10793986" y="8688031"/>
-            <a:ext cx="409487" cy="0"/>
-          </a:xfrm>
-          <a:prstGeom prst="straightConnector1">
-            <a:avLst/>
-          </a:prstGeom>
-          <a:ln>
-            <a:solidFill>
-              <a:schemeClr val="bg2">
-                <a:lumMod val="25000"/>
-              </a:schemeClr>
-            </a:solidFill>
-            <a:tailEnd type="triangle"/>
-          </a:ln>
-        </p:spPr>
-        <p:style>
-          <a:lnRef idx="2">
-            <a:schemeClr val="accent1"/>
-          </a:lnRef>
-          <a:fillRef idx="0">
-            <a:schemeClr val="accent1"/>
-          </a:fillRef>
-          <a:effectRef idx="1">
-            <a:schemeClr val="accent1"/>
-          </a:effectRef>
-          <a:fontRef idx="minor">
-            <a:schemeClr val="tx1"/>
-          </a:fontRef>
-        </p:style>
-      </p:cxnSp>
-      <p:cxnSp>
-        <p:nvCxnSpPr>
-          <p:cNvPr id="159" name="Straight Arrow Connector 158">
-            <a:extLst>
-              <a:ext uri="{FF2B5EF4-FFF2-40B4-BE49-F238E27FC236}">
-                <a16:creationId xmlns:a16="http://schemas.microsoft.com/office/drawing/2014/main" id="{6A6D25F0-6F64-E123-4AA9-3AF296331E17}"/>
-              </a:ext>
-            </a:extLst>
-          </p:cNvPr>
-          <p:cNvCxnSpPr>
-            <a:cxnSpLocks/>
-            <a:stCxn id="146" idx="2"/>
-            <a:endCxn id="139" idx="0"/>
-          </p:cNvCxnSpPr>
-          <p:nvPr/>
-        </p:nvCxnSpPr>
-        <p:spPr>
-          <a:xfrm flipH="1">
-            <a:off x="10801485" y="9665767"/>
-            <a:ext cx="421217" cy="0"/>
-          </a:xfrm>
-          <a:prstGeom prst="straightConnector1">
-            <a:avLst/>
-          </a:prstGeom>
-          <a:ln>
-            <a:solidFill>
-              <a:schemeClr val="bg2">
-                <a:lumMod val="25000"/>
-              </a:schemeClr>
-            </a:solidFill>
-            <a:headEnd type="triangle"/>
-            <a:tailEnd type="triangle"/>
-          </a:ln>
-        </p:spPr>
-        <p:style>
-          <a:lnRef idx="2">
-            <a:schemeClr val="accent1"/>
-          </a:lnRef>
-          <a:fillRef idx="0">
-            <a:schemeClr val="accent1"/>
-          </a:fillRef>
-          <a:effectRef idx="1">
-            <a:schemeClr val="accent1"/>
-          </a:effectRef>
-          <a:fontRef idx="minor">
-            <a:schemeClr val="tx1"/>
-          </a:fontRef>
-        </p:style>
-      </p:cxnSp>
-      <p:cxnSp>
-        <p:nvCxnSpPr>
-          <p:cNvPr id="168" name="Straight Arrow Connector 167">
-            <a:extLst>
-              <a:ext uri="{FF2B5EF4-FFF2-40B4-BE49-F238E27FC236}">
-                <a16:creationId xmlns:a16="http://schemas.microsoft.com/office/drawing/2014/main" id="{6F3777AF-2343-75E6-5EAA-0C5B07FAA2C3}"/>
-              </a:ext>
-            </a:extLst>
-          </p:cNvPr>
-          <p:cNvCxnSpPr>
-            <a:cxnSpLocks/>
-            <a:stCxn id="139" idx="1"/>
-            <a:endCxn id="148" idx="3"/>
-          </p:cNvCxnSpPr>
-          <p:nvPr/>
-        </p:nvCxnSpPr>
-        <p:spPr>
-          <a:xfrm>
-            <a:off x="10297872" y="9875025"/>
-            <a:ext cx="0" cy="190663"/>
-          </a:xfrm>
-          <a:prstGeom prst="straightConnector1">
-            <a:avLst/>
-          </a:prstGeom>
-          <a:ln>
-            <a:solidFill>
-              <a:schemeClr val="bg2">
-                <a:lumMod val="25000"/>
-              </a:schemeClr>
-            </a:solidFill>
-            <a:tailEnd type="triangle"/>
-          </a:ln>
-        </p:spPr>
-        <p:style>
-          <a:lnRef idx="2">
-            <a:schemeClr val="accent1"/>
-          </a:lnRef>
-          <a:fillRef idx="0">
-            <a:schemeClr val="accent1"/>
-          </a:fillRef>
-          <a:effectRef idx="1">
-            <a:schemeClr val="accent1"/>
-          </a:effectRef>
-          <a:fontRef idx="minor">
-            <a:schemeClr val="tx1"/>
-          </a:fontRef>
-        </p:style>
-      </p:cxnSp>
-      <p:cxnSp>
-        <p:nvCxnSpPr>
-          <p:cNvPr id="171" name="Connector: Elbow 170">
-            <a:extLst>
-              <a:ext uri="{FF2B5EF4-FFF2-40B4-BE49-F238E27FC236}">
-                <a16:creationId xmlns:a16="http://schemas.microsoft.com/office/drawing/2014/main" id="{D73C926A-A4E8-6697-7736-300C0C4FCD85}"/>
-              </a:ext>
-            </a:extLst>
-          </p:cNvPr>
-          <p:cNvCxnSpPr>
-            <a:cxnSpLocks/>
-            <a:stCxn id="148" idx="0"/>
-            <a:endCxn id="146" idx="1"/>
-          </p:cNvCxnSpPr>
-          <p:nvPr/>
-        </p:nvCxnSpPr>
-        <p:spPr>
-          <a:xfrm flipV="1">
-            <a:off x="10801485" y="9795164"/>
-            <a:ext cx="803977" cy="399921"/>
-          </a:xfrm>
-          <a:prstGeom prst="bentConnector2">
-            <a:avLst/>
-          </a:prstGeom>
-          <a:ln w="12700">
-            <a:solidFill>
-              <a:schemeClr val="bg2">
-                <a:lumMod val="25000"/>
-              </a:schemeClr>
-            </a:solidFill>
-            <a:tailEnd type="triangle"/>
-          </a:ln>
-        </p:spPr>
-        <p:style>
-          <a:lnRef idx="2">
-            <a:schemeClr val="accent1"/>
-          </a:lnRef>
-          <a:fillRef idx="0">
-            <a:schemeClr val="accent1"/>
-          </a:fillRef>
-          <a:effectRef idx="1">
-            <a:schemeClr val="accent1"/>
-          </a:effectRef>
-          <a:fontRef idx="minor">
-            <a:schemeClr val="tx1"/>
-          </a:fontRef>
-        </p:style>
-      </p:cxnSp>
-      <p:sp>
-        <p:nvSpPr>
-          <p:cNvPr id="174" name="Rectangle: Diagonal Corners Snipped 173">
-            <a:extLst>
-              <a:ext uri="{FF2B5EF4-FFF2-40B4-BE49-F238E27FC236}">
-                <a16:creationId xmlns:a16="http://schemas.microsoft.com/office/drawing/2014/main" id="{B0CA07B8-2FF9-2A1D-4D62-18C318C5E1D5}"/>
-              </a:ext>
-            </a:extLst>
-          </p:cNvPr>
-          <p:cNvSpPr/>
-          <p:nvPr/>
-        </p:nvSpPr>
-        <p:spPr>
-          <a:xfrm>
-            <a:off x="12409438" y="9536369"/>
-            <a:ext cx="1007226" cy="258794"/>
-          </a:xfrm>
-          <a:prstGeom prst="snip2DiagRect">
-            <a:avLst/>
-          </a:prstGeom>
-          <a:noFill/>
-          <a:ln w="6350"/>
-        </p:spPr>
-        <p:style>
-          <a:lnRef idx="2">
-            <a:schemeClr val="accent1">
-              <a:shade val="15000"/>
-            </a:schemeClr>
-          </a:lnRef>
-          <a:fillRef idx="1">
-            <a:schemeClr val="accent1"/>
-          </a:fillRef>
-          <a:effectRef idx="0">
-            <a:schemeClr val="accent1"/>
-          </a:effectRef>
-          <a:fontRef idx="minor">
-            <a:schemeClr val="lt1"/>
-          </a:fontRef>
-        </p:style>
-        <p:txBody>
-          <a:bodyPr rtlCol="0" anchor="ctr"/>
-          <a:lstStyle/>
-          <a:p>
-            <a:pPr algn="ctr"/>
-            <a:r>
-              <a:rPr lang="en-GB" sz="1050" dirty="0">
-                <a:solidFill>
-                  <a:schemeClr val="bg2">
-                    <a:lumMod val="25000"/>
-                  </a:schemeClr>
-                </a:solidFill>
-              </a:rPr>
-              <a:t>Ports Driver</a:t>
-            </a:r>
-          </a:p>
-        </p:txBody>
-      </p:sp>
-      <p:cxnSp>
-        <p:nvCxnSpPr>
-          <p:cNvPr id="175" name="Straight Arrow Connector 174">
-            <a:extLst>
-              <a:ext uri="{FF2B5EF4-FFF2-40B4-BE49-F238E27FC236}">
-                <a16:creationId xmlns:a16="http://schemas.microsoft.com/office/drawing/2014/main" id="{444D8D5F-D5DF-F174-E491-1ECB47D718C7}"/>
-              </a:ext>
-            </a:extLst>
-          </p:cNvPr>
-          <p:cNvCxnSpPr>
-            <a:cxnSpLocks/>
-            <a:stCxn id="146" idx="0"/>
-            <a:endCxn id="174" idx="2"/>
-          </p:cNvCxnSpPr>
-          <p:nvPr/>
-        </p:nvCxnSpPr>
-        <p:spPr>
-          <a:xfrm flipV="1">
-            <a:off x="11988221" y="9665766"/>
-            <a:ext cx="421217" cy="1"/>
-          </a:xfrm>
-          <a:prstGeom prst="straightConnector1">
-            <a:avLst/>
-          </a:prstGeom>
-          <a:ln>
-            <a:solidFill>
-              <a:schemeClr val="bg2">
-                <a:lumMod val="25000"/>
-              </a:schemeClr>
-            </a:solidFill>
-            <a:tailEnd type="triangle"/>
-          </a:ln>
-        </p:spPr>
-        <p:style>
-          <a:lnRef idx="2">
-            <a:schemeClr val="accent1"/>
-          </a:lnRef>
-          <a:fillRef idx="0">
-            <a:schemeClr val="accent1"/>
-          </a:fillRef>
-          <a:effectRef idx="1">
-            <a:schemeClr val="accent1"/>
-          </a:effectRef>
-          <a:fontRef idx="minor">
-            <a:schemeClr val="tx1"/>
-          </a:fontRef>
-        </p:style>
-      </p:cxnSp>
-      <p:pic>
-        <p:nvPicPr>
-          <p:cNvPr id="185" name="Picture 184">
-            <a:extLst>
-              <a:ext uri="{FF2B5EF4-FFF2-40B4-BE49-F238E27FC236}">
-                <a16:creationId xmlns:a16="http://schemas.microsoft.com/office/drawing/2014/main" id="{E8460734-C34F-7C8E-0974-B87BF0615870}"/>
-              </a:ext>
-            </a:extLst>
-          </p:cNvPr>
-          <p:cNvPicPr>
-            <a:picLocks noChangeAspect="1"/>
-          </p:cNvPicPr>
-          <p:nvPr/>
-        </p:nvPicPr>
-        <p:blipFill>
-          <a:blip r:embed="rId4"/>
-          <a:srcRect l="24252" t="10959" r="12712" b="14102"/>
-          <a:stretch>
-            <a:fillRect/>
-          </a:stretch>
-        </p:blipFill>
-        <p:spPr>
-          <a:xfrm>
-            <a:off x="4936811" y="7690990"/>
-            <a:ext cx="4361333" cy="2916487"/>
-          </a:xfrm>
-          <a:prstGeom prst="rect">
-            <a:avLst/>
-          </a:prstGeom>
-        </p:spPr>
-      </p:pic>
-      <p:sp>
-        <p:nvSpPr>
           <p:cNvPr id="186" name="TextBox 185">
             <a:extLst>
               <a:ext uri="{FF2B5EF4-FFF2-40B4-BE49-F238E27FC236}">
@@ -6092,115 +5453,127 @@
       </p:sp>
       <p:sp>
         <p:nvSpPr>
-          <p:cNvPr id="189" name="Rectangle: Diagonal Corners Snipped 188">
+          <p:cNvPr id="197" name="TextBox 196">
             <a:extLst>
               <a:ext uri="{FF2B5EF4-FFF2-40B4-BE49-F238E27FC236}">
-                <a16:creationId xmlns:a16="http://schemas.microsoft.com/office/drawing/2014/main" id="{9240BCDC-8AA1-858D-CB14-F18C6B6C4871}"/>
+                <a16:creationId xmlns:a16="http://schemas.microsoft.com/office/drawing/2014/main" id="{11F20223-3364-43A9-5F2C-19E5AF4C127E}"/>
               </a:ext>
             </a:extLst>
           </p:cNvPr>
-          <p:cNvSpPr/>
+          <p:cNvSpPr txBox="1"/>
           <p:nvPr/>
         </p:nvSpPr>
         <p:spPr>
           <a:xfrm>
-            <a:off x="11222702" y="9001896"/>
-            <a:ext cx="765519" cy="258794"/>
-          </a:xfrm>
-          <a:prstGeom prst="snip2DiagRect">
+            <a:off x="10098967" y="5572956"/>
+            <a:ext cx="1353256" cy="261610"/>
+          </a:xfrm>
+          <a:prstGeom prst="rect">
             <a:avLst/>
           </a:prstGeom>
           <a:noFill/>
-          <a:ln w="6350"/>
-        </p:spPr>
-        <p:style>
-          <a:lnRef idx="2">
-            <a:schemeClr val="accent1">
-              <a:shade val="15000"/>
-            </a:schemeClr>
-          </a:lnRef>
-          <a:fillRef idx="1">
-            <a:schemeClr val="accent1"/>
-          </a:fillRef>
-          <a:effectRef idx="0">
-            <a:schemeClr val="accent1"/>
-          </a:effectRef>
-          <a:fontRef idx="minor">
-            <a:schemeClr val="lt1"/>
-          </a:fontRef>
-        </p:style>
-        <p:txBody>
-          <a:bodyPr rtlCol="0" anchor="ctr"/>
-          <a:lstStyle/>
-          <a:p>
-            <a:pPr algn="ctr"/>
-            <a:r>
-              <a:rPr lang="en-GB" sz="1050" dirty="0">
-                <a:solidFill>
-                  <a:schemeClr val="bg2">
-                    <a:lumMod val="25000"/>
-                  </a:schemeClr>
-                </a:solidFill>
+        </p:spPr>
+        <p:txBody>
+          <a:bodyPr wrap="none" rtlCol="0" anchor="b">
+            <a:spAutoFit/>
+          </a:bodyPr>
+          <a:lstStyle/>
+          <a:p>
+            <a:pPr algn="r"/>
+            <a:r>
+              <a:rPr lang="en-GB" sz="1100" dirty="0">
+                <a:latin typeface="Segoe UI" panose="020B0502040204020203" pitchFamily="34" charset="0"/>
+                <a:cs typeface="Segoe UI" panose="020B0502040204020203" pitchFamily="34" charset="0"/>
               </a:rPr>
-              <a:t>Temp</a:t>
-            </a:r>
-          </a:p>
-        </p:txBody>
-      </p:sp>
-      <p:cxnSp>
-        <p:nvCxnSpPr>
-          <p:cNvPr id="190" name="Straight Arrow Connector 189">
+              <a:t>Command Module</a:t>
+            </a:r>
+          </a:p>
+        </p:txBody>
+      </p:sp>
+      <p:sp>
+        <p:nvSpPr>
+          <p:cNvPr id="198" name="TextBox 197">
             <a:extLst>
               <a:ext uri="{FF2B5EF4-FFF2-40B4-BE49-F238E27FC236}">
-                <a16:creationId xmlns:a16="http://schemas.microsoft.com/office/drawing/2014/main" id="{4DE1D4FB-617E-3FC8-81FC-48B17BD6DF7A}"/>
+                <a16:creationId xmlns:a16="http://schemas.microsoft.com/office/drawing/2014/main" id="{6B4585D5-132E-3262-CCFB-B5AE35F540CE}"/>
               </a:ext>
             </a:extLst>
           </p:cNvPr>
-          <p:cNvCxnSpPr>
-            <a:cxnSpLocks/>
-            <a:stCxn id="189" idx="1"/>
-            <a:endCxn id="146" idx="3"/>
-          </p:cNvCxnSpPr>
+          <p:cNvSpPr txBox="1"/>
           <p:nvPr/>
-        </p:nvCxnSpPr>
-        <p:spPr>
-          <a:xfrm>
-            <a:off x="11605462" y="9260690"/>
-            <a:ext cx="0" cy="275680"/>
-          </a:xfrm>
-          <a:prstGeom prst="straightConnector1">
+        </p:nvSpPr>
+        <p:spPr>
+          <a:xfrm>
+            <a:off x="12854157" y="5573037"/>
+            <a:ext cx="1109599" cy="261610"/>
+          </a:xfrm>
+          <a:prstGeom prst="rect">
             <a:avLst/>
           </a:prstGeom>
-          <a:ln>
-            <a:solidFill>
-              <a:schemeClr val="bg2">
-                <a:lumMod val="25000"/>
-              </a:schemeClr>
-            </a:solidFill>
-            <a:tailEnd type="triangle"/>
-          </a:ln>
-        </p:spPr>
-        <p:style>
-          <a:lnRef idx="2">
-            <a:schemeClr val="accent1"/>
-          </a:lnRef>
-          <a:fillRef idx="0">
-            <a:schemeClr val="accent1"/>
-          </a:fillRef>
-          <a:effectRef idx="1">
-            <a:schemeClr val="accent1"/>
-          </a:effectRef>
-          <a:fontRef idx="minor">
-            <a:schemeClr val="tx1"/>
-          </a:fontRef>
-        </p:style>
-      </p:cxnSp>
+          <a:noFill/>
+        </p:spPr>
+        <p:txBody>
+          <a:bodyPr wrap="none" rtlCol="0" anchor="b">
+            <a:spAutoFit/>
+          </a:bodyPr>
+          <a:lstStyle/>
+          <a:p>
+            <a:pPr algn="r"/>
+            <a:r>
+              <a:rPr lang="en-GB" sz="1100" dirty="0">
+                <a:latin typeface="Segoe UI" panose="020B0502040204020203" pitchFamily="34" charset="0"/>
+                <a:cs typeface="Segoe UI" panose="020B0502040204020203" pitchFamily="34" charset="0"/>
+              </a:rPr>
+              <a:t>Switch Module</a:t>
+            </a:r>
+          </a:p>
+        </p:txBody>
+      </p:sp>
+      <p:sp>
+        <p:nvSpPr>
+          <p:cNvPr id="199" name="TextBox 198">
+            <a:extLst>
+              <a:ext uri="{FF2B5EF4-FFF2-40B4-BE49-F238E27FC236}">
+                <a16:creationId xmlns:a16="http://schemas.microsoft.com/office/drawing/2014/main" id="{2A65E62E-951F-7BAB-6435-60968B70AEAA}"/>
+              </a:ext>
+            </a:extLst>
+          </p:cNvPr>
+          <p:cNvSpPr txBox="1"/>
+          <p:nvPr/>
+        </p:nvSpPr>
+        <p:spPr>
+          <a:xfrm>
+            <a:off x="14304480" y="5568614"/>
+            <a:ext cx="678391" cy="261610"/>
+          </a:xfrm>
+          <a:prstGeom prst="rect">
+            <a:avLst/>
+          </a:prstGeom>
+          <a:noFill/>
+        </p:spPr>
+        <p:txBody>
+          <a:bodyPr wrap="none" rtlCol="0" anchor="b">
+            <a:spAutoFit/>
+          </a:bodyPr>
+          <a:lstStyle/>
+          <a:p>
+            <a:pPr algn="r"/>
+            <a:r>
+              <a:rPr lang="en-GB" sz="1100" dirty="0">
+                <a:latin typeface="Segoe UI" panose="020B0502040204020203" pitchFamily="34" charset="0"/>
+                <a:cs typeface="Segoe UI" panose="020B0502040204020203" pitchFamily="34" charset="0"/>
+              </a:rPr>
+              <a:t>External</a:t>
+            </a:r>
+          </a:p>
+        </p:txBody>
+      </p:sp>
       <p:pic>
         <p:nvPicPr>
-          <p:cNvPr id="196" name="Picture 195">
+          <p:cNvPr id="10" name="Picture 9" descr="A computer circuit board with many different components&#10;&#10;AI-generated content may be incorrect.">
             <a:extLst>
               <a:ext uri="{FF2B5EF4-FFF2-40B4-BE49-F238E27FC236}">
-                <a16:creationId xmlns:a16="http://schemas.microsoft.com/office/drawing/2014/main" id="{CF9C3B2C-BB5C-02B6-A27B-75CD04F21474}"/>
+                <a16:creationId xmlns:a16="http://schemas.microsoft.com/office/drawing/2014/main" id="{B310AF05-D681-979F-E0F0-D4F222FC54FF}"/>
               </a:ext>
             </a:extLst>
           </p:cNvPr>
@@ -6211,15 +5584,15 @@
         </p:nvPicPr>
         <p:blipFill>
           <a:blip r:embed="rId5"/>
-          <a:srcRect l="7025" t="20577" r="12511" b="33523"/>
+          <a:srcRect l="400" t="1045" r="710" b="9353"/>
           <a:stretch>
             <a:fillRect/>
           </a:stretch>
         </p:blipFill>
         <p:spPr>
           <a:xfrm>
-            <a:off x="446526" y="9703258"/>
-            <a:ext cx="4361335" cy="988555"/>
+            <a:off x="5361293" y="962032"/>
+            <a:ext cx="3936852" cy="2734204"/>
           </a:xfrm>
           <a:prstGeom prst="rect">
             <a:avLst/>
@@ -6228,10 +5601,10 @@
       </p:pic>
       <p:sp>
         <p:nvSpPr>
-          <p:cNvPr id="197" name="TextBox 196">
+          <p:cNvPr id="13" name="TextBox 12">
             <a:extLst>
               <a:ext uri="{FF2B5EF4-FFF2-40B4-BE49-F238E27FC236}">
-                <a16:creationId xmlns:a16="http://schemas.microsoft.com/office/drawing/2014/main" id="{11F20223-3364-43A9-5F2C-19E5AF4C127E}"/>
+                <a16:creationId xmlns:a16="http://schemas.microsoft.com/office/drawing/2014/main" id="{4C6959F8-DD22-ADDB-DDE5-F3E91013D9D1}"/>
               </a:ext>
             </a:extLst>
           </p:cNvPr>
@@ -6239,9 +5612,9 @@
           <p:nvPr/>
         </p:nvSpPr>
         <p:spPr>
-          <a:xfrm>
-            <a:off x="10098967" y="4896344"/>
-            <a:ext cx="1353256" cy="261610"/>
+          <a:xfrm rot="19798013">
+            <a:off x="5753395" y="2193926"/>
+            <a:ext cx="2570832" cy="892552"/>
           </a:xfrm>
           <a:prstGeom prst="rect">
             <a:avLst/>
@@ -6249,28 +5622,48 @@
           <a:noFill/>
         </p:spPr>
         <p:txBody>
-          <a:bodyPr wrap="none" rtlCol="0" anchor="b">
+          <a:bodyPr wrap="none" rtlCol="0">
             <a:spAutoFit/>
           </a:bodyPr>
           <a:lstStyle/>
           <a:p>
-            <a:pPr algn="r"/>
-            <a:r>
-              <a:rPr lang="en-GB" sz="1100" dirty="0">
+            <a:pPr algn="ctr"/>
+            <a:r>
+              <a:rPr lang="en-GB" sz="2000" dirty="0">
                 <a:latin typeface="Segoe UI" panose="020B0502040204020203" pitchFamily="34" charset="0"/>
                 <a:cs typeface="Segoe UI" panose="020B0502040204020203" pitchFamily="34" charset="0"/>
               </a:rPr>
               <a:t>Command Module</a:t>
             </a:r>
           </a:p>
-        </p:txBody>
-      </p:sp>
-      <p:sp>
-        <p:nvSpPr>
-          <p:cNvPr id="198" name="TextBox 197">
+          <a:p>
+            <a:pPr algn="ctr"/>
+            <a:r>
+              <a:rPr lang="en-GB" sz="2000" dirty="0">
+                <a:latin typeface="Segoe UI" panose="020B0502040204020203" pitchFamily="34" charset="0"/>
+                <a:cs typeface="Segoe UI" panose="020B0502040204020203" pitchFamily="34" charset="0"/>
+              </a:rPr>
+              <a:t>Circuit</a:t>
+            </a:r>
+          </a:p>
+          <a:p>
+            <a:pPr algn="ctr"/>
+            <a:r>
+              <a:rPr lang="en-GB" sz="1200" dirty="0">
+                <a:latin typeface="Segoe UI" panose="020B0502040204020203" pitchFamily="34" charset="0"/>
+                <a:cs typeface="Segoe UI" panose="020B0502040204020203" pitchFamily="34" charset="0"/>
+              </a:rPr>
+              <a:t>(Ignore Diagram Text - Unreadable)</a:t>
+            </a:r>
+          </a:p>
+        </p:txBody>
+      </p:sp>
+      <p:sp>
+        <p:nvSpPr>
+          <p:cNvPr id="15" name="TextBox 14">
             <a:extLst>
               <a:ext uri="{FF2B5EF4-FFF2-40B4-BE49-F238E27FC236}">
-                <a16:creationId xmlns:a16="http://schemas.microsoft.com/office/drawing/2014/main" id="{6B4585D5-132E-3262-CCFB-B5AE35F540CE}"/>
+                <a16:creationId xmlns:a16="http://schemas.microsoft.com/office/drawing/2014/main" id="{8A86121A-0EBA-32F4-3C7A-CE93B209F52E}"/>
               </a:ext>
             </a:extLst>
           </p:cNvPr>
@@ -6278,9 +5671,9 @@
           <p:nvPr/>
         </p:nvSpPr>
         <p:spPr>
-          <a:xfrm>
-            <a:off x="12854157" y="4896425"/>
-            <a:ext cx="1109599" cy="261610"/>
+          <a:xfrm rot="19798013">
+            <a:off x="5569991" y="5222216"/>
+            <a:ext cx="2570832" cy="892552"/>
           </a:xfrm>
           <a:prstGeom prst="rect">
             <a:avLst/>
@@ -6288,57 +5681,64 @@
           <a:noFill/>
         </p:spPr>
         <p:txBody>
-          <a:bodyPr wrap="none" rtlCol="0" anchor="b">
+          <a:bodyPr wrap="none" rtlCol="0">
             <a:spAutoFit/>
           </a:bodyPr>
           <a:lstStyle/>
           <a:p>
-            <a:pPr algn="r"/>
-            <a:r>
-              <a:rPr lang="en-GB" sz="1100" dirty="0">
+            <a:pPr algn="ctr"/>
+            <a:r>
+              <a:rPr lang="en-GB" sz="2000" dirty="0">
                 <a:latin typeface="Segoe UI" panose="020B0502040204020203" pitchFamily="34" charset="0"/>
                 <a:cs typeface="Segoe UI" panose="020B0502040204020203" pitchFamily="34" charset="0"/>
               </a:rPr>
               <a:t>Switch Module</a:t>
             </a:r>
           </a:p>
-        </p:txBody>
-      </p:sp>
-      <p:sp>
-        <p:nvSpPr>
-          <p:cNvPr id="199" name="TextBox 198">
-            <a:extLst>
-              <a:ext uri="{FF2B5EF4-FFF2-40B4-BE49-F238E27FC236}">
-                <a16:creationId xmlns:a16="http://schemas.microsoft.com/office/drawing/2014/main" id="{2A65E62E-951F-7BAB-6435-60968B70AEAA}"/>
-              </a:ext>
-            </a:extLst>
-          </p:cNvPr>
-          <p:cNvSpPr txBox="1"/>
-          <p:nvPr/>
-        </p:nvSpPr>
-        <p:spPr>
-          <a:xfrm>
-            <a:off x="14304480" y="4892002"/>
-            <a:ext cx="678391" cy="261610"/>
-          </a:xfrm>
-          <a:prstGeom prst="rect">
-            <a:avLst/>
-          </a:prstGeom>
-          <a:noFill/>
-        </p:spPr>
-        <p:txBody>
-          <a:bodyPr wrap="none" rtlCol="0" anchor="b">
-            <a:spAutoFit/>
-          </a:bodyPr>
-          <a:lstStyle/>
-          <a:p>
-            <a:pPr algn="r"/>
-            <a:r>
-              <a:rPr lang="en-GB" sz="1100" dirty="0">
+          <a:p>
+            <a:pPr algn="ctr"/>
+            <a:r>
+              <a:rPr lang="en-GB" sz="2000" dirty="0">
                 <a:latin typeface="Segoe UI" panose="020B0502040204020203" pitchFamily="34" charset="0"/>
                 <a:cs typeface="Segoe UI" panose="020B0502040204020203" pitchFamily="34" charset="0"/>
               </a:rPr>
-              <a:t>External</a:t>
+              <a:t>Circuit</a:t>
+            </a:r>
+          </a:p>
+          <a:p>
+            <a:pPr marL="0" marR="0" lvl="0" indent="0" algn="ctr" defTabSz="457200" rtl="0" eaLnBrk="1" fontAlgn="auto" latinLnBrk="0" hangingPunct="1">
+              <a:lnSpc>
+                <a:spcPct val="100000"/>
+              </a:lnSpc>
+              <a:spcBef>
+                <a:spcPts val="0"/>
+              </a:spcBef>
+              <a:spcAft>
+                <a:spcPts val="0"/>
+              </a:spcAft>
+              <a:buClrTx/>
+              <a:buSzTx/>
+              <a:buFontTx/>
+              <a:buNone/>
+              <a:tabLst/>
+              <a:defRPr/>
+            </a:pPr>
+            <a:r>
+              <a:rPr kumimoji="0" lang="en-GB" sz="1200" b="0" i="0" u="none" strike="noStrike" kern="1200" cap="none" spc="0" normalizeH="0" baseline="0" noProof="0" dirty="0">
+                <a:ln>
+                  <a:noFill/>
+                </a:ln>
+                <a:solidFill>
+                  <a:prstClr val="black"/>
+                </a:solidFill>
+                <a:effectLst/>
+                <a:uLnTx/>
+                <a:uFillTx/>
+                <a:latin typeface="Segoe UI" panose="020B0502040204020203" pitchFamily="34" charset="0"/>
+                <a:ea typeface="+mn-ea"/>
+                <a:cs typeface="Segoe UI" panose="020B0502040204020203" pitchFamily="34" charset="0"/>
+              </a:rPr>
+              <a:t>(Ignore Diagram Text - Unreadable)</a:t>
             </a:r>
           </a:p>
         </p:txBody>

</xml_diff>